<commit_message>
Deck expanded to 17 slides (console screenshots, hard-scenarios, economy-as-data, championship case) + judge demo runbook
Co-Authored-By: Claude Fable 5 <noreply@anthropic.com>
</commit_message>
<xml_diff>
--- a/ClauseChain_Pitch_Deck.pptx
+++ b/ClauseChain_Pitch_Deck.pptx
@@ -18,9 +18,13 @@
     <p:sldId id="266" r:id="rId12"/>
     <p:sldId id="267" r:id="rId13"/>
     <p:sldId id="268" r:id="rId14"/>
+    <p:sldId id="269" r:id="rId15"/>
+    <p:sldId id="270" r:id="rId16"/>
+    <p:sldId id="271" r:id="rId17"/>
+    <p:sldId id="272" r:id="rId18"/>
   </p:sldIdLst>
   <p:notesMasterIdLst>
-    <p:notesMasterId r:id="rId15"/>
+    <p:notesMasterId r:id="rId19"/>
   </p:notesMasterIdLst>
   <p:sldSz cx="12192000" cy="6858000"/>
   <p:notesSz cx="6858000" cy="12192000"/>
@@ -890,6 +894,358 @@
             <a:fld id="{F7021451-1387-4CA6-816F-3879F97B5CBC}" type="slidenum">
               <a:rPr lang="en-US"/>
               <a:t>13</a:t>
+            </a:fld>
+            <a:endParaRPr lang="en-US"/>
+          </a:p>
+        </p:txBody>
+      </p:sp>
+    </p:spTree>
+    <p:extLst>
+      <p:ext uri="{BB962C8B-B14F-4D97-AF65-F5344CB8AC3E}">
+        <p14:creationId xmlns:p14="http://schemas.microsoft.com/office/powerpoint/2010/main" val="1024086991"/>
+      </p:ext>
+    </p:extLst>
+  </p:cSld>
+  <p:clrMapOvr>
+    <a:masterClrMapping/>
+  </p:clrMapOvr>
+</p:notes>
+</file>
+
+<file path=ppt/notesSlides/notesSlide14.xml><?xml version="1.0" encoding="utf-8"?>
+<p:notes xmlns:a="http://schemas.openxmlformats.org/drawingml/2006/main" xmlns:r="http://schemas.openxmlformats.org/officeDocument/2006/relationships" xmlns:p="http://schemas.openxmlformats.org/presentationml/2006/main">
+  <p:cSld>
+    <p:spTree>
+      <p:nvGrpSpPr>
+        <p:cNvPr id="1" name=""/>
+        <p:cNvGrpSpPr/>
+        <p:nvPr/>
+      </p:nvGrpSpPr>
+      <p:grpSpPr>
+        <a:xfrm>
+          <a:off x="0" y="0"/>
+          <a:ext cx="0" cy="0"/>
+          <a:chOff x="0" y="0"/>
+          <a:chExt cx="0" cy="0"/>
+        </a:xfrm>
+      </p:grpSpPr>
+      <p:sp>
+        <p:nvSpPr>
+          <p:cNvPr id="2" name="Slide Image Placeholder 1"/>
+          <p:cNvSpPr>
+            <a:spLocks noGrp="1" noRot="1" noChangeAspect="1"/>
+          </p:cNvSpPr>
+          <p:nvPr>
+            <p:ph type="sldImg"/>
+          </p:nvPr>
+        </p:nvSpPr>
+        <p:spPr/>
+      </p:sp>
+      <p:sp>
+        <p:nvSpPr>
+          <p:cNvPr id="3" name="Notes Placeholder 2"/>
+          <p:cNvSpPr>
+            <a:spLocks noGrp="1"/>
+          </p:cNvSpPr>
+          <p:nvPr>
+            <p:ph type="body" idx="1"/>
+          </p:nvPr>
+        </p:nvSpPr>
+        <p:spPr/>
+        <p:txBody>
+          <a:bodyPr/>
+          <a:lstStyle/>
+          <a:p>
+            <a:r>
+              <a:rPr lang="en-US" dirty="0"/>
+              <a:t/>
+            </a:r>
+            <a:endParaRPr lang="en-US" dirty="0"/>
+          </a:p>
+        </p:txBody>
+      </p:sp>
+      <p:sp>
+        <p:nvSpPr>
+          <p:cNvPr id="4" name="Slide Number Placeholder 3"/>
+          <p:cNvSpPr>
+            <a:spLocks noGrp="1"/>
+          </p:cNvSpPr>
+          <p:nvPr>
+            <p:ph type="sldNum" sz="quarter" idx="10"/>
+          </p:nvPr>
+        </p:nvSpPr>
+        <p:spPr/>
+        <p:txBody>
+          <a:bodyPr/>
+          <a:lstStyle/>
+          <a:p>
+            <a:fld id="{F7021451-1387-4CA6-816F-3879F97B5CBC}" type="slidenum">
+              <a:rPr lang="en-US"/>
+              <a:t>14</a:t>
+            </a:fld>
+            <a:endParaRPr lang="en-US"/>
+          </a:p>
+        </p:txBody>
+      </p:sp>
+    </p:spTree>
+    <p:extLst>
+      <p:ext uri="{BB962C8B-B14F-4D97-AF65-F5344CB8AC3E}">
+        <p14:creationId xmlns:p14="http://schemas.microsoft.com/office/powerpoint/2010/main" val="1024086991"/>
+      </p:ext>
+    </p:extLst>
+  </p:cSld>
+  <p:clrMapOvr>
+    <a:masterClrMapping/>
+  </p:clrMapOvr>
+</p:notes>
+</file>
+
+<file path=ppt/notesSlides/notesSlide15.xml><?xml version="1.0" encoding="utf-8"?>
+<p:notes xmlns:a="http://schemas.openxmlformats.org/drawingml/2006/main" xmlns:r="http://schemas.openxmlformats.org/officeDocument/2006/relationships" xmlns:p="http://schemas.openxmlformats.org/presentationml/2006/main">
+  <p:cSld>
+    <p:spTree>
+      <p:nvGrpSpPr>
+        <p:cNvPr id="1" name=""/>
+        <p:cNvGrpSpPr/>
+        <p:nvPr/>
+      </p:nvGrpSpPr>
+      <p:grpSpPr>
+        <a:xfrm>
+          <a:off x="0" y="0"/>
+          <a:ext cx="0" cy="0"/>
+          <a:chOff x="0" y="0"/>
+          <a:chExt cx="0" cy="0"/>
+        </a:xfrm>
+      </p:grpSpPr>
+      <p:sp>
+        <p:nvSpPr>
+          <p:cNvPr id="2" name="Slide Image Placeholder 1"/>
+          <p:cNvSpPr>
+            <a:spLocks noGrp="1" noRot="1" noChangeAspect="1"/>
+          </p:cNvSpPr>
+          <p:nvPr>
+            <p:ph type="sldImg"/>
+          </p:nvPr>
+        </p:nvSpPr>
+        <p:spPr/>
+      </p:sp>
+      <p:sp>
+        <p:nvSpPr>
+          <p:cNvPr id="3" name="Notes Placeholder 2"/>
+          <p:cNvSpPr>
+            <a:spLocks noGrp="1"/>
+          </p:cNvSpPr>
+          <p:nvPr>
+            <p:ph type="body" idx="1"/>
+          </p:nvPr>
+        </p:nvSpPr>
+        <p:spPr/>
+        <p:txBody>
+          <a:bodyPr/>
+          <a:lstStyle/>
+          <a:p>
+            <a:r>
+              <a:rPr lang="en-US" dirty="0"/>
+              <a:t/>
+            </a:r>
+            <a:endParaRPr lang="en-US" dirty="0"/>
+          </a:p>
+        </p:txBody>
+      </p:sp>
+      <p:sp>
+        <p:nvSpPr>
+          <p:cNvPr id="4" name="Slide Number Placeholder 3"/>
+          <p:cNvSpPr>
+            <a:spLocks noGrp="1"/>
+          </p:cNvSpPr>
+          <p:nvPr>
+            <p:ph type="sldNum" sz="quarter" idx="10"/>
+          </p:nvPr>
+        </p:nvSpPr>
+        <p:spPr/>
+        <p:txBody>
+          <a:bodyPr/>
+          <a:lstStyle/>
+          <a:p>
+            <a:fld id="{F7021451-1387-4CA6-816F-3879F97B5CBC}" type="slidenum">
+              <a:rPr lang="en-US"/>
+              <a:t>15</a:t>
+            </a:fld>
+            <a:endParaRPr lang="en-US"/>
+          </a:p>
+        </p:txBody>
+      </p:sp>
+    </p:spTree>
+    <p:extLst>
+      <p:ext uri="{BB962C8B-B14F-4D97-AF65-F5344CB8AC3E}">
+        <p14:creationId xmlns:p14="http://schemas.microsoft.com/office/powerpoint/2010/main" val="1024086991"/>
+      </p:ext>
+    </p:extLst>
+  </p:cSld>
+  <p:clrMapOvr>
+    <a:masterClrMapping/>
+  </p:clrMapOvr>
+</p:notes>
+</file>
+
+<file path=ppt/notesSlides/notesSlide16.xml><?xml version="1.0" encoding="utf-8"?>
+<p:notes xmlns:a="http://schemas.openxmlformats.org/drawingml/2006/main" xmlns:r="http://schemas.openxmlformats.org/officeDocument/2006/relationships" xmlns:p="http://schemas.openxmlformats.org/presentationml/2006/main">
+  <p:cSld>
+    <p:spTree>
+      <p:nvGrpSpPr>
+        <p:cNvPr id="1" name=""/>
+        <p:cNvGrpSpPr/>
+        <p:nvPr/>
+      </p:nvGrpSpPr>
+      <p:grpSpPr>
+        <a:xfrm>
+          <a:off x="0" y="0"/>
+          <a:ext cx="0" cy="0"/>
+          <a:chOff x="0" y="0"/>
+          <a:chExt cx="0" cy="0"/>
+        </a:xfrm>
+      </p:grpSpPr>
+      <p:sp>
+        <p:nvSpPr>
+          <p:cNvPr id="2" name="Slide Image Placeholder 1"/>
+          <p:cNvSpPr>
+            <a:spLocks noGrp="1" noRot="1" noChangeAspect="1"/>
+          </p:cNvSpPr>
+          <p:nvPr>
+            <p:ph type="sldImg"/>
+          </p:nvPr>
+        </p:nvSpPr>
+        <p:spPr/>
+      </p:sp>
+      <p:sp>
+        <p:nvSpPr>
+          <p:cNvPr id="3" name="Notes Placeholder 2"/>
+          <p:cNvSpPr>
+            <a:spLocks noGrp="1"/>
+          </p:cNvSpPr>
+          <p:nvPr>
+            <p:ph type="body" idx="1"/>
+          </p:nvPr>
+        </p:nvSpPr>
+        <p:spPr/>
+        <p:txBody>
+          <a:bodyPr/>
+          <a:lstStyle/>
+          <a:p>
+            <a:r>
+              <a:rPr lang="en-US" dirty="0"/>
+              <a:t/>
+            </a:r>
+            <a:endParaRPr lang="en-US" dirty="0"/>
+          </a:p>
+        </p:txBody>
+      </p:sp>
+      <p:sp>
+        <p:nvSpPr>
+          <p:cNvPr id="4" name="Slide Number Placeholder 3"/>
+          <p:cNvSpPr>
+            <a:spLocks noGrp="1"/>
+          </p:cNvSpPr>
+          <p:nvPr>
+            <p:ph type="sldNum" sz="quarter" idx="10"/>
+          </p:nvPr>
+        </p:nvSpPr>
+        <p:spPr/>
+        <p:txBody>
+          <a:bodyPr/>
+          <a:lstStyle/>
+          <a:p>
+            <a:fld id="{F7021451-1387-4CA6-816F-3879F97B5CBC}" type="slidenum">
+              <a:rPr lang="en-US"/>
+              <a:t>16</a:t>
+            </a:fld>
+            <a:endParaRPr lang="en-US"/>
+          </a:p>
+        </p:txBody>
+      </p:sp>
+    </p:spTree>
+    <p:extLst>
+      <p:ext uri="{BB962C8B-B14F-4D97-AF65-F5344CB8AC3E}">
+        <p14:creationId xmlns:p14="http://schemas.microsoft.com/office/powerpoint/2010/main" val="1024086991"/>
+      </p:ext>
+    </p:extLst>
+  </p:cSld>
+  <p:clrMapOvr>
+    <a:masterClrMapping/>
+  </p:clrMapOvr>
+</p:notes>
+</file>
+
+<file path=ppt/notesSlides/notesSlide17.xml><?xml version="1.0" encoding="utf-8"?>
+<p:notes xmlns:a="http://schemas.openxmlformats.org/drawingml/2006/main" xmlns:r="http://schemas.openxmlformats.org/officeDocument/2006/relationships" xmlns:p="http://schemas.openxmlformats.org/presentationml/2006/main">
+  <p:cSld>
+    <p:spTree>
+      <p:nvGrpSpPr>
+        <p:cNvPr id="1" name=""/>
+        <p:cNvGrpSpPr/>
+        <p:nvPr/>
+      </p:nvGrpSpPr>
+      <p:grpSpPr>
+        <a:xfrm>
+          <a:off x="0" y="0"/>
+          <a:ext cx="0" cy="0"/>
+          <a:chOff x="0" y="0"/>
+          <a:chExt cx="0" cy="0"/>
+        </a:xfrm>
+      </p:grpSpPr>
+      <p:sp>
+        <p:nvSpPr>
+          <p:cNvPr id="2" name="Slide Image Placeholder 1"/>
+          <p:cNvSpPr>
+            <a:spLocks noGrp="1" noRot="1" noChangeAspect="1"/>
+          </p:cNvSpPr>
+          <p:nvPr>
+            <p:ph type="sldImg"/>
+          </p:nvPr>
+        </p:nvSpPr>
+        <p:spPr/>
+      </p:sp>
+      <p:sp>
+        <p:nvSpPr>
+          <p:cNvPr id="3" name="Notes Placeholder 2"/>
+          <p:cNvSpPr>
+            <a:spLocks noGrp="1"/>
+          </p:cNvSpPr>
+          <p:nvPr>
+            <p:ph type="body" idx="1"/>
+          </p:nvPr>
+        </p:nvSpPr>
+        <p:spPr/>
+        <p:txBody>
+          <a:bodyPr/>
+          <a:lstStyle/>
+          <a:p>
+            <a:r>
+              <a:rPr lang="en-US" dirty="0"/>
+              <a:t/>
+            </a:r>
+            <a:endParaRPr lang="en-US" dirty="0"/>
+          </a:p>
+        </p:txBody>
+      </p:sp>
+      <p:sp>
+        <p:nvSpPr>
+          <p:cNvPr id="4" name="Slide Number Placeholder 3"/>
+          <p:cNvSpPr>
+            <a:spLocks noGrp="1"/>
+          </p:cNvSpPr>
+          <p:nvPr>
+            <p:ph type="sldNum" sz="quarter" idx="10"/>
+          </p:nvPr>
+        </p:nvSpPr>
+        <p:spPr/>
+        <p:txBody>
+          <a:bodyPr/>
+          <a:lstStyle/>
+          <a:p>
+            <a:fld id="{F7021451-1387-4CA6-816F-3879F97B5CBC}" type="slidenum">
+              <a:rPr lang="en-US"/>
+              <a:t>17</a:t>
             </a:fld>
             <a:endParaRPr lang="en-US"/>
           </a:p>
@@ -3127,7 +3483,7 @@
                 <a:ea typeface="Calibri" pitchFamily="34" charset="-122"/>
                 <a:cs typeface="Calibri" pitchFamily="34" charset="-120"/>
               </a:rPr>
-              <a:t>WHY THIS WINS ON TRUST</a:t>
+              <a:t>ONE ENGINE, TWO ENTRY POINTS: CLI AND WEB</a:t>
             </a:r>
             <a:endParaRPr lang="en-US" sz="1200" dirty="0"/>
           </a:p>
@@ -3166,7 +3522,7 @@
                 <a:ea typeface="Cambria" pitchFamily="34" charset="-122"/>
                 <a:cs typeface="Cambria" pitchFamily="34" charset="-120"/>
               </a:rPr>
-              <a:t>Innovation &amp; Competitive Advantage</a:t>
+              <a:t>The Judge-Facing Console</a:t>
             </a:r>
             <a:endParaRPr lang="en-US" sz="3400" dirty="0"/>
           </a:p>
@@ -3180,12 +3536,182 @@
         </p:nvSpPr>
         <p:spPr>
           <a:xfrm>
-            <a:off x="548640" y="1463040"/>
-            <a:ext cx="5440680" cy="1572768"/>
+            <a:off x="493776" y="1408176"/>
+            <a:ext cx="5550408" cy="3227832"/>
           </a:xfrm>
           <a:prstGeom prst="roundRect">
             <a:avLst>
-              <a:gd name="adj" fmla="val 4651"/>
+              <a:gd name="adj" fmla="val 1700"/>
+            </a:avLst>
+          </a:prstGeom>
+          <a:solidFill>
+            <a:srgbClr val="E3EBF3"/>
+          </a:solidFill>
+          <a:ln/>
+        </p:spPr>
+      </p:sp>
+      <p:pic>
+        <p:nvPicPr>
+          <p:cNvPr id="5" name="Image 0" descr="/private/tmp/claude-501/-Users-nafew-Documents-Web-Projects-ClauseChain/00809bd9-8f8d-442e-95ce-81f2f310946c/scratchpad/d6r-dashboard.jpg">    </p:cNvPr>
+          <p:cNvPicPr>
+            <a:picLocks noChangeAspect="1"/>
+          </p:cNvPicPr>
+          <p:nvPr/>
+        </p:nvPicPr>
+        <p:blipFill>
+          <a:blip r:embed="rId1"/>
+          <a:stretch>
+            <a:fillRect/>
+          </a:stretch>
+        </p:blipFill>
+        <p:spPr>
+          <a:xfrm>
+            <a:off x="548640" y="1463040"/>
+            <a:ext cx="5440680" cy="3063240"/>
+          </a:xfrm>
+          <a:prstGeom prst="rect">
+            <a:avLst/>
+          </a:prstGeom>
+        </p:spPr>
+      </p:pic>
+      <p:sp>
+        <p:nvSpPr>
+          <p:cNvPr id="6" name="Text 3"/>
+          <p:cNvSpPr/>
+          <p:nvPr/>
+        </p:nvSpPr>
+        <p:spPr>
+          <a:xfrm>
+            <a:off x="548640" y="4617720"/>
+            <a:ext cx="5440680" cy="548640"/>
+          </a:xfrm>
+          <a:prstGeom prst="rect">
+            <a:avLst/>
+          </a:prstGeom>
+          <a:noFill/>
+          <a:ln/>
+        </p:spPr>
+        <p:txBody>
+          <a:bodyPr wrap="square" rtlCol="0" anchor="t"/>
+          <a:lstStyle/>
+          <a:p>
+            <a:pPr indent="0" marL="0">
+              <a:buNone/>
+            </a:pPr>
+            <a:r>
+              <a:rPr lang="en-US" sz="1100" dirty="0">
+                <a:solidFill>
+                  <a:srgbClr val="5C6B7A"/>
+                </a:solidFill>
+                <a:latin typeface="Calibri" pitchFamily="34" charset="0"/>
+                <a:ea typeface="Calibri" pitchFamily="34" charset="-122"/>
+                <a:cs typeface="Calibri" pitchFamily="34" charset="-120"/>
+              </a:rPr>
+              <a:t>Workspace dashboard — live run status, corpus counts, review queues</a:t>
+            </a:r>
+            <a:endParaRPr lang="en-US" sz="1100" dirty="0"/>
+          </a:p>
+        </p:txBody>
+      </p:sp>
+      <p:sp>
+        <p:nvSpPr>
+          <p:cNvPr id="7" name="Shape 4"/>
+          <p:cNvSpPr/>
+          <p:nvPr/>
+        </p:nvSpPr>
+        <p:spPr>
+          <a:xfrm>
+            <a:off x="6117336" y="1408176"/>
+            <a:ext cx="5550408" cy="3227832"/>
+          </a:xfrm>
+          <a:prstGeom prst="roundRect">
+            <a:avLst>
+              <a:gd name="adj" fmla="val 1700"/>
+            </a:avLst>
+          </a:prstGeom>
+          <a:solidFill>
+            <a:srgbClr val="E3EBF3"/>
+          </a:solidFill>
+          <a:ln/>
+        </p:spPr>
+      </p:sp>
+      <p:pic>
+        <p:nvPicPr>
+          <p:cNvPr id="8" name="Image 1" descr="/private/tmp/claude-501/-Users-nafew-Documents-Web-Projects-ClauseChain/00809bd9-8f8d-442e-95ce-81f2f310946c/scratchpad/review-desktop-1440-final.jpg">    </p:cNvPr>
+          <p:cNvPicPr>
+            <a:picLocks noChangeAspect="1"/>
+          </p:cNvPicPr>
+          <p:nvPr/>
+        </p:nvPicPr>
+        <p:blipFill>
+          <a:blip r:embed="rId2"/>
+          <a:stretch>
+            <a:fillRect/>
+          </a:stretch>
+        </p:blipFill>
+        <p:spPr>
+          <a:xfrm>
+            <a:off x="6172200" y="1463040"/>
+            <a:ext cx="5440680" cy="3063240"/>
+          </a:xfrm>
+          <a:prstGeom prst="rect">
+            <a:avLst/>
+          </a:prstGeom>
+        </p:spPr>
+      </p:pic>
+      <p:sp>
+        <p:nvSpPr>
+          <p:cNvPr id="9" name="Text 5"/>
+          <p:cNvSpPr/>
+          <p:nvPr/>
+        </p:nvSpPr>
+        <p:spPr>
+          <a:xfrm>
+            <a:off x="6172200" y="4617720"/>
+            <a:ext cx="5440680" cy="548640"/>
+          </a:xfrm>
+          <a:prstGeom prst="rect">
+            <a:avLst/>
+          </a:prstGeom>
+          <a:noFill/>
+          <a:ln/>
+        </p:spPr>
+        <p:txBody>
+          <a:bodyPr wrap="square" rtlCol="0" anchor="t"/>
+          <a:lstStyle/>
+          <a:p>
+            <a:pPr indent="0" marL="0">
+              <a:buNone/>
+            </a:pPr>
+            <a:r>
+              <a:rPr lang="en-US" sz="1100" dirty="0">
+                <a:solidFill>
+                  <a:srgbClr val="5C6B7A"/>
+                </a:solidFill>
+                <a:latin typeface="Calibri" pitchFamily="34" charset="0"/>
+                <a:ea typeface="Calibri" pitchFamily="34" charset="-122"/>
+                <a:cs typeface="Calibri" pitchFamily="34" charset="-120"/>
+              </a:rPr>
+              <a:t>Review screen — source context, gate results, refuter verdict, named role-separated sign-off</a:t>
+            </a:r>
+            <a:endParaRPr lang="en-US" sz="1100" dirty="0"/>
+          </a:p>
+        </p:txBody>
+      </p:sp>
+      <p:sp>
+        <p:nvSpPr>
+          <p:cNvPr id="10" name="Shape 6"/>
+          <p:cNvSpPr/>
+          <p:nvPr/>
+        </p:nvSpPr>
+        <p:spPr>
+          <a:xfrm>
+            <a:off x="548640" y="5257800"/>
+            <a:ext cx="11064240" cy="1051560"/>
+          </a:xfrm>
+          <a:prstGeom prst="roundRect">
+            <a:avLst>
+              <a:gd name="adj" fmla="val 6957"/>
             </a:avLst>
           </a:prstGeom>
           <a:solidFill>
@@ -3196,14 +3722,14 @@
       </p:sp>
       <p:sp>
         <p:nvSpPr>
-          <p:cNvPr id="5" name="Text 3"/>
-          <p:cNvSpPr/>
-          <p:nvPr/>
-        </p:nvSpPr>
-        <p:spPr>
-          <a:xfrm>
-            <a:off x="777240" y="1572768"/>
-            <a:ext cx="4983480" cy="365760"/>
+          <p:cNvPr id="11" name="Text 7"/>
+          <p:cNvSpPr/>
+          <p:nvPr/>
+        </p:nvSpPr>
+        <p:spPr>
+          <a:xfrm>
+            <a:off x="822960" y="5349240"/>
+            <a:ext cx="10515600" cy="868680"/>
           </a:xfrm>
           <a:prstGeom prst="rect">
             <a:avLst/>
@@ -3219,46 +3745,21 @@
               <a:buNone/>
             </a:pPr>
             <a:r>
-              <a:rPr lang="en-US" sz="1400" b="1" dirty="0">
-                <a:solidFill>
-                  <a:srgbClr val="14548F"/>
-                </a:solidFill>
-                <a:latin typeface="Calibri" pitchFamily="34" charset="0"/>
-                <a:ea typeface="Calibri" pitchFamily="34" charset="-122"/>
-                <a:cs typeface="Calibri" pitchFamily="34" charset="-120"/>
-              </a:rPr>
-              <a:t>Treaty-evidenced 6.5</a:t>
-            </a:r>
-            <a:endParaRPr lang="en-US" sz="1400" dirty="0"/>
-          </a:p>
-        </p:txBody>
-      </p:sp>
-      <p:sp>
-        <p:nvSpPr>
-          <p:cNvPr id="6" name="Text 4"/>
-          <p:cNvSpPr/>
-          <p:nvPr/>
-        </p:nvSpPr>
-        <p:spPr>
-          <a:xfrm>
-            <a:off x="777240" y="1920240"/>
-            <a:ext cx="4983480" cy="1042416"/>
-          </a:xfrm>
-          <a:prstGeom prst="rect">
-            <a:avLst/>
-          </a:prstGeom>
-          <a:noFill/>
-          <a:ln/>
-        </p:spPr>
-        <p:txBody>
-          <a:bodyPr wrap="square" rtlCol="0" anchor="t"/>
-          <a:lstStyle/>
-          <a:p>
-            <a:pPr indent="0" marL="0">
-              <a:buNone/>
-            </a:pPr>
-            <a:r>
-              <a:rPr lang="en-US" sz="1080" dirty="0">
+              <a:rPr lang="en-US" sz="1250" b="1" dirty="0">
+                <a:solidFill>
+                  <a:srgbClr val="0F2A47"/>
+                </a:solidFill>
+                <a:latin typeface="Calibri" pitchFamily="34" charset="0"/>
+                <a:ea typeface="Calibri" pitchFamily="34" charset="-122"/>
+                <a:cs typeface="Calibri" pitchFamily="34" charset="-120"/>
+              </a:rPr>
+              <a:t>Same allowlisted engine behind both: </a:t>
+            </a:r>
+            <a:pPr indent="0" marL="0">
+              <a:buNone/>
+            </a:pPr>
+            <a:r>
+              <a:rPr lang="en-US" sz="1250" dirty="0">
                 <a:solidFill>
                   <a:srgbClr val="24303C"/>
                 </a:solidFill>
@@ -3266,509 +3767,9 @@
                 <a:ea typeface="Calibri" pitchFamily="34" charset="-122"/>
                 <a:cs typeface="Calibri" pitchFamily="34" charset="-120"/>
               </a:rPr>
-              <a:t>P6-I5 rows cite the actual binding commitments (CPTPP Art. 14.11, DEPA Art. 4.3, RCEP Art. 12.15) parsed from official state registers through the same generic pipeline — no hand-curated rows anywhere.</a:t>
-            </a:r>
-            <a:endParaRPr lang="en-US" sz="1080" dirty="0"/>
-          </a:p>
-        </p:txBody>
-      </p:sp>
-      <p:sp>
-        <p:nvSpPr>
-          <p:cNvPr id="7" name="Shape 5"/>
-          <p:cNvSpPr/>
-          <p:nvPr/>
-        </p:nvSpPr>
-        <p:spPr>
-          <a:xfrm>
-            <a:off x="6172200" y="1463040"/>
-            <a:ext cx="5440680" cy="1572768"/>
-          </a:xfrm>
-          <a:prstGeom prst="roundRect">
-            <a:avLst>
-              <a:gd name="adj" fmla="val 4651"/>
-            </a:avLst>
-          </a:prstGeom>
-          <a:solidFill>
-            <a:srgbClr val="FDF6E9"/>
-          </a:solidFill>
-          <a:ln/>
-        </p:spPr>
-      </p:sp>
-      <p:sp>
-        <p:nvSpPr>
-          <p:cNvPr id="8" name="Text 6"/>
-          <p:cNvSpPr/>
-          <p:nvPr/>
-        </p:nvSpPr>
-        <p:spPr>
-          <a:xfrm>
-            <a:off x="6400800" y="1572768"/>
-            <a:ext cx="4983480" cy="365760"/>
-          </a:xfrm>
-          <a:prstGeom prst="rect">
-            <a:avLst/>
-          </a:prstGeom>
-          <a:noFill/>
-          <a:ln/>
-        </p:spPr>
-        <p:txBody>
-          <a:bodyPr wrap="square" rtlCol="0" anchor="ctr"/>
-          <a:lstStyle/>
-          <a:p>
-            <a:pPr indent="0" marL="0">
-              <a:buNone/>
-            </a:pPr>
-            <a:r>
-              <a:rPr lang="en-US" sz="1400" b="1" dirty="0">
-                <a:solidFill>
-                  <a:srgbClr val="A2711D"/>
-                </a:solidFill>
-                <a:latin typeface="Calibri" pitchFamily="34" charset="0"/>
-                <a:ea typeface="Calibri" pitchFamily="34" charset="-122"/>
-                <a:cs typeface="Calibri" pitchFamily="34" charset="-120"/>
-              </a:rPr>
-              <a:t>We audit the gold</a:t>
-            </a:r>
-            <a:endParaRPr lang="en-US" sz="1400" dirty="0"/>
-          </a:p>
-        </p:txBody>
-      </p:sp>
-      <p:sp>
-        <p:nvSpPr>
-          <p:cNvPr id="9" name="Text 7"/>
-          <p:cNvSpPr/>
-          <p:nvPr/>
-        </p:nvSpPr>
-        <p:spPr>
-          <a:xfrm>
-            <a:off x="6400800" y="1920240"/>
-            <a:ext cx="4983480" cy="1042416"/>
-          </a:xfrm>
-          <a:prstGeom prst="rect">
-            <a:avLst/>
-          </a:prstGeom>
-          <a:noFill/>
-          <a:ln/>
-        </p:spPr>
-        <p:txBody>
-          <a:bodyPr wrap="square" rtlCol="0" anchor="t"/>
-          <a:lstStyle/>
-          <a:p>
-            <a:pPr indent="0" marL="0">
-              <a:buNone/>
-            </a:pPr>
-            <a:r>
-              <a:rPr lang="en-US" sz="1080" dirty="0">
-                <a:solidFill>
-                  <a:srgbClr val="24303C"/>
-                </a:solidFill>
-                <a:latin typeface="Calibri" pitchFamily="34" charset="0"/>
-                <a:ea typeface="Calibri" pitchFamily="34" charset="-122"/>
-                <a:cs typeface="Calibri" pitchFamily="34" charset="-120"/>
-              </a:rPr>
-              <a:t>The engine re-verifies the provided master data and caught its planted Malaysia errors — including citations to clauses that do not exist — filing corrections with evidence.</a:t>
-            </a:r>
-            <a:endParaRPr lang="en-US" sz="1080" dirty="0"/>
-          </a:p>
-        </p:txBody>
-      </p:sp>
-      <p:sp>
-        <p:nvSpPr>
-          <p:cNvPr id="10" name="Shape 8"/>
-          <p:cNvSpPr/>
-          <p:nvPr/>
-        </p:nvSpPr>
-        <p:spPr>
-          <a:xfrm>
-            <a:off x="548640" y="3182112"/>
-            <a:ext cx="5440680" cy="1572768"/>
-          </a:xfrm>
-          <a:prstGeom prst="roundRect">
-            <a:avLst>
-              <a:gd name="adj" fmla="val 4651"/>
-            </a:avLst>
-          </a:prstGeom>
-          <a:solidFill>
-            <a:srgbClr val="EDF5FC"/>
-          </a:solidFill>
-          <a:ln/>
-        </p:spPr>
-      </p:sp>
-      <p:sp>
-        <p:nvSpPr>
-          <p:cNvPr id="11" name="Text 9"/>
-          <p:cNvSpPr/>
-          <p:nvPr/>
-        </p:nvSpPr>
-        <p:spPr>
-          <a:xfrm>
-            <a:off x="777240" y="3291840"/>
-            <a:ext cx="4983480" cy="365760"/>
-          </a:xfrm>
-          <a:prstGeom prst="rect">
-            <a:avLst/>
-          </a:prstGeom>
-          <a:noFill/>
-          <a:ln/>
-        </p:spPr>
-        <p:txBody>
-          <a:bodyPr wrap="square" rtlCol="0" anchor="ctr"/>
-          <a:lstStyle/>
-          <a:p>
-            <a:pPr indent="0" marL="0">
-              <a:buNone/>
-            </a:pPr>
-            <a:r>
-              <a:rPr lang="en-US" sz="1400" b="1" dirty="0">
-                <a:solidFill>
-                  <a:srgbClr val="14548F"/>
-                </a:solidFill>
-                <a:latin typeface="Calibri" pitchFamily="34" charset="0"/>
-                <a:ea typeface="Calibri" pitchFamily="34" charset="-122"/>
-                <a:cs typeface="Calibri" pitchFamily="34" charset="-120"/>
-              </a:rPr>
-              <a:t>Absence is proven</a:t>
-            </a:r>
-            <a:endParaRPr lang="en-US" sz="1400" dirty="0"/>
-          </a:p>
-        </p:txBody>
-      </p:sp>
-      <p:sp>
-        <p:nvSpPr>
-          <p:cNvPr id="12" name="Text 10"/>
-          <p:cNvSpPr/>
-          <p:nvPr/>
-        </p:nvSpPr>
-        <p:spPr>
-          <a:xfrm>
-            <a:off x="777240" y="3639312"/>
-            <a:ext cx="4983480" cy="1042416"/>
-          </a:xfrm>
-          <a:prstGeom prst="rect">
-            <a:avLst/>
-          </a:prstGeom>
-          <a:noFill/>
-          <a:ln/>
-        </p:spPr>
-        <p:txBody>
-          <a:bodyPr wrap="square" rtlCol="0" anchor="t"/>
-          <a:lstStyle/>
-          <a:p>
-            <a:pPr indent="0" marL="0">
-              <a:buNone/>
-            </a:pPr>
-            <a:r>
-              <a:rPr lang="en-US" sz="1080" dirty="0">
-                <a:solidFill>
-                  <a:srgbClr val="24303C"/>
-                </a:solidFill>
-                <a:latin typeface="Calibri" pitchFamily="34" charset="0"/>
-                <a:ea typeface="Calibri" pitchFamily="34" charset="-122"/>
-                <a:cs typeface="Calibri" pitchFamily="34" charset="-120"/>
-              </a:rPr>
-              <a:t>Score-0 claims carry a search-coverage manifest; unresolved acquisitions (e.g. a geo-blocked treaty register) BLOCK the absence conclusion instead of faking it.</a:t>
-            </a:r>
-            <a:endParaRPr lang="en-US" sz="1080" dirty="0"/>
-          </a:p>
-        </p:txBody>
-      </p:sp>
-      <p:sp>
-        <p:nvSpPr>
-          <p:cNvPr id="13" name="Shape 11"/>
-          <p:cNvSpPr/>
-          <p:nvPr/>
-        </p:nvSpPr>
-        <p:spPr>
-          <a:xfrm>
-            <a:off x="6172200" y="3182112"/>
-            <a:ext cx="5440680" cy="1572768"/>
-          </a:xfrm>
-          <a:prstGeom prst="roundRect">
-            <a:avLst>
-              <a:gd name="adj" fmla="val 4651"/>
-            </a:avLst>
-          </a:prstGeom>
-          <a:solidFill>
-            <a:srgbClr val="EDF5FC"/>
-          </a:solidFill>
-          <a:ln/>
-        </p:spPr>
-      </p:sp>
-      <p:sp>
-        <p:nvSpPr>
-          <p:cNvPr id="14" name="Text 12"/>
-          <p:cNvSpPr/>
-          <p:nvPr/>
-        </p:nvSpPr>
-        <p:spPr>
-          <a:xfrm>
-            <a:off x="6400800" y="3291840"/>
-            <a:ext cx="4983480" cy="365760"/>
-          </a:xfrm>
-          <a:prstGeom prst="rect">
-            <a:avLst/>
-          </a:prstGeom>
-          <a:noFill/>
-          <a:ln/>
-        </p:spPr>
-        <p:txBody>
-          <a:bodyPr wrap="square" rtlCol="0" anchor="ctr"/>
-          <a:lstStyle/>
-          <a:p>
-            <a:pPr indent="0" marL="0">
-              <a:buNone/>
-            </a:pPr>
-            <a:r>
-              <a:rPr lang="en-US" sz="1400" b="1" dirty="0">
-                <a:solidFill>
-                  <a:srgbClr val="14548F"/>
-                </a:solidFill>
-                <a:latin typeface="Calibri" pitchFamily="34" charset="0"/>
-                <a:ea typeface="Calibri" pitchFamily="34" charset="-122"/>
-                <a:cs typeface="Calibri" pitchFamily="34" charset="-120"/>
-              </a:rPr>
-              <a:t>Uncertainty is modelled</a:t>
-            </a:r>
-            <a:endParaRPr lang="en-US" sz="1400" dirty="0"/>
-          </a:p>
-        </p:txBody>
-      </p:sp>
-      <p:sp>
-        <p:nvSpPr>
-          <p:cNvPr id="15" name="Text 13"/>
-          <p:cNvSpPr/>
-          <p:nvPr/>
-        </p:nvSpPr>
-        <p:spPr>
-          <a:xfrm>
-            <a:off x="6400800" y="3639312"/>
-            <a:ext cx="4983480" cy="1042416"/>
-          </a:xfrm>
-          <a:prstGeom prst="rect">
-            <a:avLst/>
-          </a:prstGeom>
-          <a:noFill/>
-          <a:ln/>
-        </p:spPr>
-        <p:txBody>
-          <a:bodyPr wrap="square" rtlCol="0" anchor="t"/>
-          <a:lstStyle/>
-          <a:p>
-            <a:pPr indent="0" marL="0">
-              <a:buNone/>
-            </a:pPr>
-            <a:r>
-              <a:rPr lang="en-US" sz="1080" dirty="0">
-                <a:solidFill>
-                  <a:srgbClr val="24303C"/>
-                </a:solidFill>
-                <a:latin typeface="Calibri" pitchFamily="34" charset="0"/>
-                <a:ea typeface="Calibri" pitchFamily="34" charset="-122"/>
-                <a:cs typeface="Calibri" pitchFamily="34" charset="-120"/>
-              </a:rPr>
-              <a:t>Zone-3 scores ship a multi-persona noise audit (Krippendorff’s α) and a master-gold tripwire — a band with receipts, never a bare number.</a:t>
-            </a:r>
-            <a:endParaRPr lang="en-US" sz="1080" dirty="0"/>
-          </a:p>
-        </p:txBody>
-      </p:sp>
-      <p:sp>
-        <p:nvSpPr>
-          <p:cNvPr id="16" name="Shape 14"/>
-          <p:cNvSpPr/>
-          <p:nvPr/>
-        </p:nvSpPr>
-        <p:spPr>
-          <a:xfrm>
-            <a:off x="548640" y="4901184"/>
-            <a:ext cx="5440680" cy="1572768"/>
-          </a:xfrm>
-          <a:prstGeom prst="roundRect">
-            <a:avLst>
-              <a:gd name="adj" fmla="val 4651"/>
-            </a:avLst>
-          </a:prstGeom>
-          <a:solidFill>
-            <a:srgbClr val="EDF5FC"/>
-          </a:solidFill>
-          <a:ln/>
-        </p:spPr>
-      </p:sp>
-      <p:sp>
-        <p:nvSpPr>
-          <p:cNvPr id="17" name="Text 15"/>
-          <p:cNvSpPr/>
-          <p:nvPr/>
-        </p:nvSpPr>
-        <p:spPr>
-          <a:xfrm>
-            <a:off x="777240" y="5010912"/>
-            <a:ext cx="4983480" cy="365760"/>
-          </a:xfrm>
-          <a:prstGeom prst="rect">
-            <a:avLst/>
-          </a:prstGeom>
-          <a:noFill/>
-          <a:ln/>
-        </p:spPr>
-        <p:txBody>
-          <a:bodyPr wrap="square" rtlCol="0" anchor="ctr"/>
-          <a:lstStyle/>
-          <a:p>
-            <a:pPr indent="0" marL="0">
-              <a:buNone/>
-            </a:pPr>
-            <a:r>
-              <a:rPr lang="en-US" sz="1400" b="1" dirty="0">
-                <a:solidFill>
-                  <a:srgbClr val="14548F"/>
-                </a:solidFill>
-                <a:latin typeface="Calibri" pitchFamily="34" charset="0"/>
-                <a:ea typeface="Calibri" pitchFamily="34" charset="-122"/>
-                <a:cs typeface="Calibri" pitchFamily="34" charset="-120"/>
-              </a:rPr>
-              <a:t>Human-authoritative by design</a:t>
-            </a:r>
-            <a:endParaRPr lang="en-US" sz="1400" dirty="0"/>
-          </a:p>
-        </p:txBody>
-      </p:sp>
-      <p:sp>
-        <p:nvSpPr>
-          <p:cNvPr id="18" name="Text 16"/>
-          <p:cNvSpPr/>
-          <p:nvPr/>
-        </p:nvSpPr>
-        <p:spPr>
-          <a:xfrm>
-            <a:off x="777240" y="5358384"/>
-            <a:ext cx="4983480" cy="1042416"/>
-          </a:xfrm>
-          <a:prstGeom prst="rect">
-            <a:avLst/>
-          </a:prstGeom>
-          <a:noFill/>
-          <a:ln/>
-        </p:spPr>
-        <p:txBody>
-          <a:bodyPr wrap="square" rtlCol="0" anchor="t"/>
-          <a:lstStyle/>
-          <a:p>
-            <a:pPr indent="0" marL="0">
-              <a:buNone/>
-            </a:pPr>
-            <a:r>
-              <a:rPr lang="en-US" sz="1080" dirty="0">
-                <a:solidFill>
-                  <a:srgbClr val="24303C"/>
-                </a:solidFill>
-                <a:latin typeface="Calibri" pitchFamily="34" charset="0"/>
-                <a:ea typeface="Calibri" pitchFamily="34" charset="-122"/>
-                <a:cs typeface="Calibri" pitchFamily="34" charset="-120"/>
-              </a:rPr>
-              <a:t>Citation reviewer ≠ mapping reviewer, enforced at write time; append-only receipts; the submission is replayable from decisions alone.</a:t>
-            </a:r>
-            <a:endParaRPr lang="en-US" sz="1080" dirty="0"/>
-          </a:p>
-        </p:txBody>
-      </p:sp>
-      <p:sp>
-        <p:nvSpPr>
-          <p:cNvPr id="19" name="Shape 17"/>
-          <p:cNvSpPr/>
-          <p:nvPr/>
-        </p:nvSpPr>
-        <p:spPr>
-          <a:xfrm>
-            <a:off x="6172200" y="4901184"/>
-            <a:ext cx="5440680" cy="1572768"/>
-          </a:xfrm>
-          <a:prstGeom prst="roundRect">
-            <a:avLst>
-              <a:gd name="adj" fmla="val 4651"/>
-            </a:avLst>
-          </a:prstGeom>
-          <a:solidFill>
-            <a:srgbClr val="EDF5FC"/>
-          </a:solidFill>
-          <a:ln/>
-        </p:spPr>
-      </p:sp>
-      <p:sp>
-        <p:nvSpPr>
-          <p:cNvPr id="20" name="Text 18"/>
-          <p:cNvSpPr/>
-          <p:nvPr/>
-        </p:nvSpPr>
-        <p:spPr>
-          <a:xfrm>
-            <a:off x="6400800" y="5010912"/>
-            <a:ext cx="4983480" cy="365760"/>
-          </a:xfrm>
-          <a:prstGeom prst="rect">
-            <a:avLst/>
-          </a:prstGeom>
-          <a:noFill/>
-          <a:ln/>
-        </p:spPr>
-        <p:txBody>
-          <a:bodyPr wrap="square" rtlCol="0" anchor="ctr"/>
-          <a:lstStyle/>
-          <a:p>
-            <a:pPr indent="0" marL="0">
-              <a:buNone/>
-            </a:pPr>
-            <a:r>
-              <a:rPr lang="en-US" sz="1400" b="1" dirty="0">
-                <a:solidFill>
-                  <a:srgbClr val="14548F"/>
-                </a:solidFill>
-                <a:latin typeface="Calibri" pitchFamily="34" charset="0"/>
-                <a:ea typeface="Calibri" pitchFamily="34" charset="-122"/>
-                <a:cs typeface="Calibri" pitchFamily="34" charset="-120"/>
-              </a:rPr>
-              <a:t>Generic to the core</a:t>
-            </a:r>
-            <a:endParaRPr lang="en-US" sz="1400" dirty="0"/>
-          </a:p>
-        </p:txBody>
-      </p:sp>
-      <p:sp>
-        <p:nvSpPr>
-          <p:cNvPr id="21" name="Text 19"/>
-          <p:cNvSpPr/>
-          <p:nvPr/>
-        </p:nvSpPr>
-        <p:spPr>
-          <a:xfrm>
-            <a:off x="6400800" y="5358384"/>
-            <a:ext cx="4983480" cy="1042416"/>
-          </a:xfrm>
-          <a:prstGeom prst="rect">
-            <a:avLst/>
-          </a:prstGeom>
-          <a:noFill/>
-          <a:ln/>
-        </p:spPr>
-        <p:txBody>
-          <a:bodyPr wrap="square" rtlCol="0" anchor="t"/>
-          <a:lstStyle/>
-          <a:p>
-            <a:pPr indent="0" marL="0">
-              <a:buNone/>
-            </a:pPr>
-            <a:r>
-              <a:rPr lang="en-US" sz="1080" dirty="0">
-                <a:solidFill>
-                  <a:srgbClr val="24303C"/>
-                </a:solidFill>
-                <a:latin typeface="Calibri" pitchFamily="34" charset="0"/>
-                <a:ea typeface="Calibri" pitchFamily="34" charset="-122"/>
-                <a:cs typeface="Calibri" pitchFamily="34" charset="-120"/>
-              </a:rPr>
-              <a:t>Nothing in code names a statute or a row: targets live in seeds/YAML data. The rerun that added treaties, Malay grammar and subsidiary legislation changed configuration, not engine logic.</a:t>
-            </a:r>
-            <a:endParaRPr lang="en-US" sz="1080" dirty="0"/>
+              <a:t>the web console triggers runs through an admin-gated, argv-allowlisted worker (no shell), streams progress, and writes review decisions through the same sanctioned CLI the terminal uses — receipts either way.</a:t>
+            </a:r>
+            <a:endParaRPr lang="en-US" sz="1250" dirty="0"/>
           </a:p>
         </p:txBody>
       </p:sp>
@@ -3837,7 +3838,7 @@
                 <a:ea typeface="Calibri" pitchFamily="34" charset="-122"/>
                 <a:cs typeface="Calibri" pitchFamily="34" charset="-120"/>
               </a:rPr>
-              <a:t>FROM 3 ECONOMIES TO THE REGION</a:t>
+              <a:t>WHY THIS WINS ON TRUST</a:t>
             </a:r>
             <a:endParaRPr lang="en-US" sz="1200" dirty="0"/>
           </a:p>
@@ -3876,7 +3877,7 @@
                 <a:ea typeface="Cambria" pitchFamily="34" charset="-122"/>
                 <a:cs typeface="Cambria" pitchFamily="34" charset="-120"/>
               </a:rPr>
-              <a:t>Scalability &amp; Future Development</a:t>
+              <a:t>Innovation &amp; Competitive Advantage</a:t>
             </a:r>
             <a:endParaRPr lang="en-US" sz="3400" dirty="0"/>
           </a:p>
@@ -3890,12 +3891,12 @@
         </p:nvSpPr>
         <p:spPr>
           <a:xfrm>
-            <a:off x="548640" y="1417320"/>
-            <a:ext cx="5486400" cy="4800600"/>
+            <a:off x="548640" y="1463040"/>
+            <a:ext cx="5440680" cy="1572768"/>
           </a:xfrm>
           <a:prstGeom prst="roundRect">
             <a:avLst>
-              <a:gd name="adj" fmla="val 1524"/>
+              <a:gd name="adj" fmla="val 4651"/>
             </a:avLst>
           </a:prstGeom>
           <a:solidFill>
@@ -3912,8 +3913,8 @@
         </p:nvSpPr>
         <p:spPr>
           <a:xfrm>
-            <a:off x="822960" y="1600200"/>
-            <a:ext cx="4937760" cy="320040"/>
+            <a:off x="777240" y="1572768"/>
+            <a:ext cx="4983480" cy="365760"/>
           </a:xfrm>
           <a:prstGeom prst="rect">
             <a:avLst/>
@@ -3929,17 +3930,17 @@
               <a:buNone/>
             </a:pPr>
             <a:r>
-              <a:rPr lang="en-US" sz="1300" b="1" spc="100" kern="0" dirty="0">
-                <a:solidFill>
-                  <a:srgbClr val="0E9E8E"/>
-                </a:solidFill>
-                <a:latin typeface="Calibri" pitchFamily="34" charset="0"/>
-                <a:ea typeface="Calibri" pitchFamily="34" charset="-122"/>
-                <a:cs typeface="Calibri" pitchFamily="34" charset="-120"/>
-              </a:rPr>
-              <a:t>SCALE PATH</a:t>
-            </a:r>
-            <a:endParaRPr lang="en-US" sz="1300" dirty="0"/>
+              <a:rPr lang="en-US" sz="1400" b="1" dirty="0">
+                <a:solidFill>
+                  <a:srgbClr val="14548F"/>
+                </a:solidFill>
+                <a:latin typeface="Calibri" pitchFamily="34" charset="0"/>
+                <a:ea typeface="Calibri" pitchFamily="34" charset="-122"/>
+                <a:cs typeface="Calibri" pitchFamily="34" charset="-120"/>
+              </a:rPr>
+              <a:t>Treaty-evidenced 6.5</a:t>
+            </a:r>
+            <a:endParaRPr lang="en-US" sz="1400" dirty="0"/>
           </a:p>
         </p:txBody>
       </p:sp>
@@ -3951,8 +3952,8 @@
         </p:nvSpPr>
         <p:spPr>
           <a:xfrm>
-            <a:off x="822960" y="1965960"/>
-            <a:ext cx="4937760" cy="4023360"/>
+            <a:off x="777240" y="1920240"/>
+            <a:ext cx="4983480" cy="1042416"/>
           </a:xfrm>
           <a:prstGeom prst="rect">
             <a:avLst/>
@@ -3964,15 +3965,11 @@
           <a:bodyPr wrap="square" rtlCol="0" anchor="t"/>
           <a:lstStyle/>
           <a:p>
-            <a:pPr marL="342900" indent="-342900">
-              <a:spcAft>
-                <a:spcPts val="800"/>
-              </a:spcAft>
-              <a:buSzPct val="100000"/>
-              <a:buChar char="•"/>
-            </a:pPr>
-            <a:r>
-              <a:rPr lang="en-US" sz="1150" dirty="0">
+            <a:pPr indent="0" marL="0">
+              <a:buNone/>
+            </a:pPr>
+            <a:r>
+              <a:rPr lang="en-US" sz="1080" dirty="0">
                 <a:solidFill>
                   <a:srgbClr val="24303C"/>
                 </a:solidFill>
@@ -3980,69 +3977,9 @@
                 <a:ea typeface="Calibri" pitchFamily="34" charset="-122"/>
                 <a:cs typeface="Calibri" pitchFamily="34" charset="-120"/>
               </a:rPr>
-              <a:t>New economy = data, not code: a jurisdiction YAML (portals, citation grammar, status assertions) + seed rows. Extractors are format-based; grammars are named profiles ("Pasal", "Статья", "มาตรา" next).</a:t>
-            </a:r>
-            <a:endParaRPr lang="en-US" sz="1150" dirty="0"/>
-          </a:p>
-          <a:p>
-            <a:pPr marL="342900" indent="-342900">
-              <a:spcAft>
-                <a:spcPts val="800"/>
-              </a:spcAft>
-              <a:buSzPct val="100000"/>
-              <a:buChar char="•"/>
-            </a:pPr>
-            <a:r>
-              <a:rPr lang="en-US" sz="1150" dirty="0">
-                <a:solidFill>
-                  <a:srgbClr val="24303C"/>
-                </a:solidFill>
-                <a:latin typeface="Calibri" pitchFamily="34" charset="0"/>
-                <a:ea typeface="Calibri" pitchFamily="34" charset="-122"/>
-                <a:cs typeface="Calibri" pitchFamily="34" charset="-120"/>
-              </a:rPr>
-              <a:t>Finals-ready gold: the government-verified Round-2 database (CN·IN·ID·LA·MN·RU·TH) is already ingested as the evaluation baseline for the 8-economy expansion.</a:t>
-            </a:r>
-            <a:endParaRPr lang="en-US" sz="1150" dirty="0"/>
-          </a:p>
-          <a:p>
-            <a:pPr marL="342900" indent="-342900">
-              <a:spcAft>
-                <a:spcPts val="800"/>
-              </a:spcAft>
-              <a:buSzPct val="100000"/>
-              <a:buChar char="•"/>
-            </a:pPr>
-            <a:r>
-              <a:rPr lang="en-US" sz="1150" dirty="0">
-                <a:solidFill>
-                  <a:srgbClr val="24303C"/>
-                </a:solidFill>
-                <a:latin typeface="Calibri" pitchFamily="34" charset="0"/>
-                <a:ea typeface="Calibri" pitchFamily="34" charset="-122"/>
-                <a:cs typeface="Calibri" pitchFamily="34" charset="-120"/>
-              </a:rPr>
-              <a:t>Multilingual by architecture: BGE-M3 cross-lingual retrieval, original-language verbatim + appended English column, per-language section grammars.</a:t>
-            </a:r>
-            <a:endParaRPr lang="en-US" sz="1150" dirty="0"/>
-          </a:p>
-          <a:p>
-            <a:pPr marL="342900" indent="-342900">
-              <a:buSzPct val="100000"/>
-              <a:buChar char="•"/>
-            </a:pPr>
-            <a:r>
-              <a:rPr lang="en-US" sz="1150" dirty="0">
-                <a:solidFill>
-                  <a:srgbClr val="24303C"/>
-                </a:solidFill>
-                <a:latin typeface="Calibri" pitchFamily="34" charset="0"/>
-                <a:ea typeface="Calibri" pitchFamily="34" charset="-122"/>
-                <a:cs typeface="Calibri" pitchFamily="34" charset="-120"/>
-              </a:rPr>
-              <a:t>Continuous monitoring: incremental fingerprints mean a nightly run re-extracts only changed documents — amendment tracking falls out of the cache design.</a:t>
-            </a:r>
-            <a:endParaRPr lang="en-US" sz="1150" dirty="0"/>
+              <a:t>P6-I5 rows cite the actual binding commitments (CPTPP Art. 14.11, DEPA Art. 4.3, RCEP Art. 12.15) parsed from official state registers through the same generic pipeline — no hand-curated rows anywhere.</a:t>
+            </a:r>
+            <a:endParaRPr lang="en-US" sz="1080" dirty="0"/>
           </a:p>
         </p:txBody>
       </p:sp>
@@ -4054,16 +3991,16 @@
         </p:nvSpPr>
         <p:spPr>
           <a:xfrm>
-            <a:off x="6309360" y="1417320"/>
-            <a:ext cx="5303520" cy="4800600"/>
+            <a:off x="6172200" y="1463040"/>
+            <a:ext cx="5440680" cy="1572768"/>
           </a:xfrm>
           <a:prstGeom prst="roundRect">
             <a:avLst>
-              <a:gd name="adj" fmla="val 1524"/>
+              <a:gd name="adj" fmla="val 4651"/>
             </a:avLst>
           </a:prstGeom>
           <a:solidFill>
-            <a:srgbClr val="F3FBF9"/>
+            <a:srgbClr val="FDF6E9"/>
           </a:solidFill>
           <a:ln/>
         </p:spPr>
@@ -4076,8 +4013,8 @@
         </p:nvSpPr>
         <p:spPr>
           <a:xfrm>
-            <a:off x="6583680" y="1600200"/>
-            <a:ext cx="4754880" cy="320040"/>
+            <a:off x="6400800" y="1572768"/>
+            <a:ext cx="4983480" cy="365760"/>
           </a:xfrm>
           <a:prstGeom prst="rect">
             <a:avLst/>
@@ -4093,17 +4030,17 @@
               <a:buNone/>
             </a:pPr>
             <a:r>
-              <a:rPr lang="en-US" sz="1300" b="1" spc="100" kern="0" dirty="0">
-                <a:solidFill>
-                  <a:srgbClr val="0E9E8E"/>
-                </a:solidFill>
-                <a:latin typeface="Calibri" pitchFamily="34" charset="0"/>
-                <a:ea typeface="Calibri" pitchFamily="34" charset="-122"/>
-                <a:cs typeface="Calibri" pitchFamily="34" charset="-120"/>
-              </a:rPr>
-              <a:t>VALUE FOR ESCAP &amp; STAKEHOLDERS</a:t>
-            </a:r>
-            <a:endParaRPr lang="en-US" sz="1300" dirty="0"/>
+              <a:rPr lang="en-US" sz="1400" b="1" dirty="0">
+                <a:solidFill>
+                  <a:srgbClr val="A2711D"/>
+                </a:solidFill>
+                <a:latin typeface="Calibri" pitchFamily="34" charset="0"/>
+                <a:ea typeface="Calibri" pitchFamily="34" charset="-122"/>
+                <a:cs typeface="Calibri" pitchFamily="34" charset="-120"/>
+              </a:rPr>
+              <a:t>We audit the gold</a:t>
+            </a:r>
+            <a:endParaRPr lang="en-US" sz="1400" dirty="0"/>
           </a:p>
         </p:txBody>
       </p:sp>
@@ -4115,8 +4052,8 @@
         </p:nvSpPr>
         <p:spPr>
           <a:xfrm>
-            <a:off x="6583680" y="1965960"/>
-            <a:ext cx="4754880" cy="4023360"/>
+            <a:off x="6400800" y="1920240"/>
+            <a:ext cx="4983480" cy="1042416"/>
           </a:xfrm>
           <a:prstGeom prst="rect">
             <a:avLst/>
@@ -4128,15 +4065,11 @@
           <a:bodyPr wrap="square" rtlCol="0" anchor="t"/>
           <a:lstStyle/>
           <a:p>
-            <a:pPr marL="342900" indent="-342900">
-              <a:spcAft>
-                <a:spcPts val="800"/>
-              </a:spcAft>
-              <a:buSzPct val="100000"/>
-              <a:buChar char="•"/>
-            </a:pPr>
-            <a:r>
-              <a:rPr lang="en-US" sz="1150" dirty="0">
+            <a:pPr indent="0" marL="0">
+              <a:buNone/>
+            </a:pPr>
+            <a:r>
+              <a:rPr lang="en-US" sz="1080" dirty="0">
                 <a:solidFill>
                   <a:srgbClr val="24303C"/>
                 </a:solidFill>
@@ -4144,20 +4077,99 @@
                 <a:ea typeface="Calibri" pitchFamily="34" charset="-122"/>
                 <a:cs typeface="Calibri" pitchFamily="34" charset="-120"/>
               </a:rPr>
-              <a:t>ESCAP researchers — RDTII updates in hours instead of months, with every cell traceable to an archived official source.</a:t>
-            </a:r>
-            <a:endParaRPr lang="en-US" sz="1150" dirty="0"/>
-          </a:p>
-          <a:p>
-            <a:pPr marL="342900" indent="-342900">
-              <a:spcAft>
-                <a:spcPts val="800"/>
-              </a:spcAft>
-              <a:buSzPct val="100000"/>
-              <a:buChar char="•"/>
-            </a:pPr>
-            <a:r>
-              <a:rPr lang="en-US" sz="1150" dirty="0">
+              <a:t>The engine re-verifies the provided master data and caught its planted Malaysia errors — including citations to clauses that do not exist — filing corrections with evidence.</a:t>
+            </a:r>
+            <a:endParaRPr lang="en-US" sz="1080" dirty="0"/>
+          </a:p>
+        </p:txBody>
+      </p:sp>
+      <p:sp>
+        <p:nvSpPr>
+          <p:cNvPr id="10" name="Shape 8"/>
+          <p:cNvSpPr/>
+          <p:nvPr/>
+        </p:nvSpPr>
+        <p:spPr>
+          <a:xfrm>
+            <a:off x="548640" y="3182112"/>
+            <a:ext cx="5440680" cy="1572768"/>
+          </a:xfrm>
+          <a:prstGeom prst="roundRect">
+            <a:avLst>
+              <a:gd name="adj" fmla="val 4651"/>
+            </a:avLst>
+          </a:prstGeom>
+          <a:solidFill>
+            <a:srgbClr val="EDF5FC"/>
+          </a:solidFill>
+          <a:ln/>
+        </p:spPr>
+      </p:sp>
+      <p:sp>
+        <p:nvSpPr>
+          <p:cNvPr id="11" name="Text 9"/>
+          <p:cNvSpPr/>
+          <p:nvPr/>
+        </p:nvSpPr>
+        <p:spPr>
+          <a:xfrm>
+            <a:off x="777240" y="3291840"/>
+            <a:ext cx="4983480" cy="365760"/>
+          </a:xfrm>
+          <a:prstGeom prst="rect">
+            <a:avLst/>
+          </a:prstGeom>
+          <a:noFill/>
+          <a:ln/>
+        </p:spPr>
+        <p:txBody>
+          <a:bodyPr wrap="square" rtlCol="0" anchor="ctr"/>
+          <a:lstStyle/>
+          <a:p>
+            <a:pPr indent="0" marL="0">
+              <a:buNone/>
+            </a:pPr>
+            <a:r>
+              <a:rPr lang="en-US" sz="1400" b="1" dirty="0">
+                <a:solidFill>
+                  <a:srgbClr val="14548F"/>
+                </a:solidFill>
+                <a:latin typeface="Calibri" pitchFamily="34" charset="0"/>
+                <a:ea typeface="Calibri" pitchFamily="34" charset="-122"/>
+                <a:cs typeface="Calibri" pitchFamily="34" charset="-120"/>
+              </a:rPr>
+              <a:t>Absence is proven</a:t>
+            </a:r>
+            <a:endParaRPr lang="en-US" sz="1400" dirty="0"/>
+          </a:p>
+        </p:txBody>
+      </p:sp>
+      <p:sp>
+        <p:nvSpPr>
+          <p:cNvPr id="12" name="Text 10"/>
+          <p:cNvSpPr/>
+          <p:nvPr/>
+        </p:nvSpPr>
+        <p:spPr>
+          <a:xfrm>
+            <a:off x="777240" y="3639312"/>
+            <a:ext cx="4983480" cy="1042416"/>
+          </a:xfrm>
+          <a:prstGeom prst="rect">
+            <a:avLst/>
+          </a:prstGeom>
+          <a:noFill/>
+          <a:ln/>
+        </p:spPr>
+        <p:txBody>
+          <a:bodyPr wrap="square" rtlCol="0" anchor="t"/>
+          <a:lstStyle/>
+          <a:p>
+            <a:pPr indent="0" marL="0">
+              <a:buNone/>
+            </a:pPr>
+            <a:r>
+              <a:rPr lang="en-US" sz="1080" dirty="0">
                 <a:solidFill>
                   <a:srgbClr val="24303C"/>
                 </a:solidFill>
@@ -4165,20 +4177,99 @@
                 <a:ea typeface="Calibri" pitchFamily="34" charset="-122"/>
                 <a:cs typeface="Calibri" pitchFamily="34" charset="-120"/>
               </a:rPr>
-              <a:t>Governments — see exactly which provision produced each score; corrections become data changes with receipts.</a:t>
-            </a:r>
-            <a:endParaRPr lang="en-US" sz="1150" dirty="0"/>
-          </a:p>
-          <a:p>
-            <a:pPr marL="342900" indent="-342900">
-              <a:spcAft>
-                <a:spcPts val="800"/>
-              </a:spcAft>
-              <a:buSzPct val="100000"/>
-              <a:buChar char="•"/>
-            </a:pPr>
-            <a:r>
-              <a:rPr lang="en-US" sz="1150" dirty="0">
+              <a:t>Score-0 claims carry a search-coverage manifest; unresolved acquisitions (e.g. a geo-blocked treaty register) BLOCK the absence conclusion instead of faking it.</a:t>
+            </a:r>
+            <a:endParaRPr lang="en-US" sz="1080" dirty="0"/>
+          </a:p>
+        </p:txBody>
+      </p:sp>
+      <p:sp>
+        <p:nvSpPr>
+          <p:cNvPr id="13" name="Shape 11"/>
+          <p:cNvSpPr/>
+          <p:nvPr/>
+        </p:nvSpPr>
+        <p:spPr>
+          <a:xfrm>
+            <a:off x="6172200" y="3182112"/>
+            <a:ext cx="5440680" cy="1572768"/>
+          </a:xfrm>
+          <a:prstGeom prst="roundRect">
+            <a:avLst>
+              <a:gd name="adj" fmla="val 4651"/>
+            </a:avLst>
+          </a:prstGeom>
+          <a:solidFill>
+            <a:srgbClr val="EDF5FC"/>
+          </a:solidFill>
+          <a:ln/>
+        </p:spPr>
+      </p:sp>
+      <p:sp>
+        <p:nvSpPr>
+          <p:cNvPr id="14" name="Text 12"/>
+          <p:cNvSpPr/>
+          <p:nvPr/>
+        </p:nvSpPr>
+        <p:spPr>
+          <a:xfrm>
+            <a:off x="6400800" y="3291840"/>
+            <a:ext cx="4983480" cy="365760"/>
+          </a:xfrm>
+          <a:prstGeom prst="rect">
+            <a:avLst/>
+          </a:prstGeom>
+          <a:noFill/>
+          <a:ln/>
+        </p:spPr>
+        <p:txBody>
+          <a:bodyPr wrap="square" rtlCol="0" anchor="ctr"/>
+          <a:lstStyle/>
+          <a:p>
+            <a:pPr indent="0" marL="0">
+              <a:buNone/>
+            </a:pPr>
+            <a:r>
+              <a:rPr lang="en-US" sz="1400" b="1" dirty="0">
+                <a:solidFill>
+                  <a:srgbClr val="14548F"/>
+                </a:solidFill>
+                <a:latin typeface="Calibri" pitchFamily="34" charset="0"/>
+                <a:ea typeface="Calibri" pitchFamily="34" charset="-122"/>
+                <a:cs typeface="Calibri" pitchFamily="34" charset="-120"/>
+              </a:rPr>
+              <a:t>Uncertainty is modelled</a:t>
+            </a:r>
+            <a:endParaRPr lang="en-US" sz="1400" dirty="0"/>
+          </a:p>
+        </p:txBody>
+      </p:sp>
+      <p:sp>
+        <p:nvSpPr>
+          <p:cNvPr id="15" name="Text 13"/>
+          <p:cNvSpPr/>
+          <p:nvPr/>
+        </p:nvSpPr>
+        <p:spPr>
+          <a:xfrm>
+            <a:off x="6400800" y="3639312"/>
+            <a:ext cx="4983480" cy="1042416"/>
+          </a:xfrm>
+          <a:prstGeom prst="rect">
+            <a:avLst/>
+          </a:prstGeom>
+          <a:noFill/>
+          <a:ln/>
+        </p:spPr>
+        <p:txBody>
+          <a:bodyPr wrap="square" rtlCol="0" anchor="t"/>
+          <a:lstStyle/>
+          <a:p>
+            <a:pPr indent="0" marL="0">
+              <a:buNone/>
+            </a:pPr>
+            <a:r>
+              <a:rPr lang="en-US" sz="1080" dirty="0">
                 <a:solidFill>
                   <a:srgbClr val="24303C"/>
                 </a:solidFill>
@@ -4186,17 +4277,99 @@
                 <a:ea typeface="Calibri" pitchFamily="34" charset="-122"/>
                 <a:cs typeface="Calibri" pitchFamily="34" charset="-120"/>
               </a:rPr>
-              <a:t>Businesses &amp; trade lawyers — pinpoint, current, verifiable answers on cross-border data rules across jurisdictions.</a:t>
-            </a:r>
-            <a:endParaRPr lang="en-US" sz="1150" dirty="0"/>
-          </a:p>
-          <a:p>
-            <a:pPr marL="342900" indent="-342900">
-              <a:buSzPct val="100000"/>
-              <a:buChar char="•"/>
-            </a:pPr>
-            <a:r>
-              <a:rPr lang="en-US" sz="1150" dirty="0">
+              <a:t>Zone-3 scores ship a multi-persona noise audit (Krippendorff’s α) and a master-gold tripwire — a band with receipts, never a bare number.</a:t>
+            </a:r>
+            <a:endParaRPr lang="en-US" sz="1080" dirty="0"/>
+          </a:p>
+        </p:txBody>
+      </p:sp>
+      <p:sp>
+        <p:nvSpPr>
+          <p:cNvPr id="16" name="Shape 14"/>
+          <p:cNvSpPr/>
+          <p:nvPr/>
+        </p:nvSpPr>
+        <p:spPr>
+          <a:xfrm>
+            <a:off x="548640" y="4901184"/>
+            <a:ext cx="5440680" cy="1572768"/>
+          </a:xfrm>
+          <a:prstGeom prst="roundRect">
+            <a:avLst>
+              <a:gd name="adj" fmla="val 4651"/>
+            </a:avLst>
+          </a:prstGeom>
+          <a:solidFill>
+            <a:srgbClr val="EDF5FC"/>
+          </a:solidFill>
+          <a:ln/>
+        </p:spPr>
+      </p:sp>
+      <p:sp>
+        <p:nvSpPr>
+          <p:cNvPr id="17" name="Text 15"/>
+          <p:cNvSpPr/>
+          <p:nvPr/>
+        </p:nvSpPr>
+        <p:spPr>
+          <a:xfrm>
+            <a:off x="777240" y="5010912"/>
+            <a:ext cx="4983480" cy="365760"/>
+          </a:xfrm>
+          <a:prstGeom prst="rect">
+            <a:avLst/>
+          </a:prstGeom>
+          <a:noFill/>
+          <a:ln/>
+        </p:spPr>
+        <p:txBody>
+          <a:bodyPr wrap="square" rtlCol="0" anchor="ctr"/>
+          <a:lstStyle/>
+          <a:p>
+            <a:pPr indent="0" marL="0">
+              <a:buNone/>
+            </a:pPr>
+            <a:r>
+              <a:rPr lang="en-US" sz="1400" b="1" dirty="0">
+                <a:solidFill>
+                  <a:srgbClr val="14548F"/>
+                </a:solidFill>
+                <a:latin typeface="Calibri" pitchFamily="34" charset="0"/>
+                <a:ea typeface="Calibri" pitchFamily="34" charset="-122"/>
+                <a:cs typeface="Calibri" pitchFamily="34" charset="-120"/>
+              </a:rPr>
+              <a:t>Human-authoritative by design</a:t>
+            </a:r>
+            <a:endParaRPr lang="en-US" sz="1400" dirty="0"/>
+          </a:p>
+        </p:txBody>
+      </p:sp>
+      <p:sp>
+        <p:nvSpPr>
+          <p:cNvPr id="18" name="Text 16"/>
+          <p:cNvSpPr/>
+          <p:nvPr/>
+        </p:nvSpPr>
+        <p:spPr>
+          <a:xfrm>
+            <a:off x="777240" y="5358384"/>
+            <a:ext cx="4983480" cy="1042416"/>
+          </a:xfrm>
+          <a:prstGeom prst="rect">
+            <a:avLst/>
+          </a:prstGeom>
+          <a:noFill/>
+          <a:ln/>
+        </p:spPr>
+        <p:txBody>
+          <a:bodyPr wrap="square" rtlCol="0" anchor="t"/>
+          <a:lstStyle/>
+          <a:p>
+            <a:pPr indent="0" marL="0">
+              <a:buNone/>
+            </a:pPr>
+            <a:r>
+              <a:rPr lang="en-US" sz="1080" dirty="0">
                 <a:solidFill>
                   <a:srgbClr val="24303C"/>
                 </a:solidFill>
@@ -4204,9 +4377,109 @@
                 <a:ea typeface="Calibri" pitchFamily="34" charset="-122"/>
                 <a:cs typeface="Calibri" pitchFamily="34" charset="-120"/>
               </a:rPr>
-              <a:t>Expected outcomes — faster policy insight, fewer stale citations, lower compliance-research burden, and a reusable evidence commons for digital-trade regulation.</a:t>
-            </a:r>
-            <a:endParaRPr lang="en-US" sz="1150" dirty="0"/>
+              <a:t>Citation reviewer ≠ mapping reviewer, enforced at write time; append-only receipts; the submission is replayable from decisions alone.</a:t>
+            </a:r>
+            <a:endParaRPr lang="en-US" sz="1080" dirty="0"/>
+          </a:p>
+        </p:txBody>
+      </p:sp>
+      <p:sp>
+        <p:nvSpPr>
+          <p:cNvPr id="19" name="Shape 17"/>
+          <p:cNvSpPr/>
+          <p:nvPr/>
+        </p:nvSpPr>
+        <p:spPr>
+          <a:xfrm>
+            <a:off x="6172200" y="4901184"/>
+            <a:ext cx="5440680" cy="1572768"/>
+          </a:xfrm>
+          <a:prstGeom prst="roundRect">
+            <a:avLst>
+              <a:gd name="adj" fmla="val 4651"/>
+            </a:avLst>
+          </a:prstGeom>
+          <a:solidFill>
+            <a:srgbClr val="EDF5FC"/>
+          </a:solidFill>
+          <a:ln/>
+        </p:spPr>
+      </p:sp>
+      <p:sp>
+        <p:nvSpPr>
+          <p:cNvPr id="20" name="Text 18"/>
+          <p:cNvSpPr/>
+          <p:nvPr/>
+        </p:nvSpPr>
+        <p:spPr>
+          <a:xfrm>
+            <a:off x="6400800" y="5010912"/>
+            <a:ext cx="4983480" cy="365760"/>
+          </a:xfrm>
+          <a:prstGeom prst="rect">
+            <a:avLst/>
+          </a:prstGeom>
+          <a:noFill/>
+          <a:ln/>
+        </p:spPr>
+        <p:txBody>
+          <a:bodyPr wrap="square" rtlCol="0" anchor="ctr"/>
+          <a:lstStyle/>
+          <a:p>
+            <a:pPr indent="0" marL="0">
+              <a:buNone/>
+            </a:pPr>
+            <a:r>
+              <a:rPr lang="en-US" sz="1400" b="1" dirty="0">
+                <a:solidFill>
+                  <a:srgbClr val="14548F"/>
+                </a:solidFill>
+                <a:latin typeface="Calibri" pitchFamily="34" charset="0"/>
+                <a:ea typeface="Calibri" pitchFamily="34" charset="-122"/>
+                <a:cs typeface="Calibri" pitchFamily="34" charset="-120"/>
+              </a:rPr>
+              <a:t>Generic to the core</a:t>
+            </a:r>
+            <a:endParaRPr lang="en-US" sz="1400" dirty="0"/>
+          </a:p>
+        </p:txBody>
+      </p:sp>
+      <p:sp>
+        <p:nvSpPr>
+          <p:cNvPr id="21" name="Text 19"/>
+          <p:cNvSpPr/>
+          <p:nvPr/>
+        </p:nvSpPr>
+        <p:spPr>
+          <a:xfrm>
+            <a:off x="6400800" y="5358384"/>
+            <a:ext cx="4983480" cy="1042416"/>
+          </a:xfrm>
+          <a:prstGeom prst="rect">
+            <a:avLst/>
+          </a:prstGeom>
+          <a:noFill/>
+          <a:ln/>
+        </p:spPr>
+        <p:txBody>
+          <a:bodyPr wrap="square" rtlCol="0" anchor="t"/>
+          <a:lstStyle/>
+          <a:p>
+            <a:pPr indent="0" marL="0">
+              <a:buNone/>
+            </a:pPr>
+            <a:r>
+              <a:rPr lang="en-US" sz="1080" dirty="0">
+                <a:solidFill>
+                  <a:srgbClr val="24303C"/>
+                </a:solidFill>
+                <a:latin typeface="Calibri" pitchFamily="34" charset="0"/>
+                <a:ea typeface="Calibri" pitchFamily="34" charset="-122"/>
+                <a:cs typeface="Calibri" pitchFamily="34" charset="-120"/>
+              </a:rPr>
+              <a:t>Nothing in code names a statute or a row: targets live in seeds/YAML data. The rerun that added treaties, Malay grammar and subsidiary legislation changed configuration, not engine logic.</a:t>
+            </a:r>
+            <a:endParaRPr lang="en-US" sz="1080" dirty="0"/>
           </a:p>
         </p:txBody>
       </p:sp>
@@ -4221,6 +4494,2550 @@
 <file path=ppt/slides/slide13.xml><?xml version="1.0" encoding="utf-8"?>
 <p:sld xmlns:a="http://schemas.openxmlformats.org/drawingml/2006/main" xmlns:r="http://schemas.openxmlformats.org/officeDocument/2006/relationships" xmlns:p="http://schemas.openxmlformats.org/presentationml/2006/main">
   <p:cSld name="Slide 13">
+    <p:bg>
+      <p:bgPr>
+        <a:solidFill>
+          <a:srgbClr val="FFFFFF"/>
+        </a:solidFill>
+      </p:bgPr>
+    </p:bg>
+    <p:spTree>
+      <p:nvGrpSpPr>
+        <p:cNvPr id="1" name=""/>
+        <p:cNvGrpSpPr/>
+        <p:nvPr/>
+      </p:nvGrpSpPr>
+      <p:grpSpPr>
+        <a:xfrm>
+          <a:off x="0" y="0"/>
+          <a:ext cx="0" cy="0"/>
+          <a:chOff x="0" y="0"/>
+          <a:chExt cx="0" cy="0"/>
+        </a:xfrm>
+      </p:grpSpPr>
+      <p:sp>
+        <p:nvSpPr>
+          <p:cNvPr id="2" name="Text 0"/>
+          <p:cNvSpPr/>
+          <p:nvPr/>
+        </p:nvSpPr>
+        <p:spPr>
+          <a:xfrm>
+            <a:off x="548640" y="292608"/>
+            <a:ext cx="11064240" cy="292608"/>
+          </a:xfrm>
+          <a:prstGeom prst="rect">
+            <a:avLst/>
+          </a:prstGeom>
+          <a:noFill/>
+          <a:ln/>
+        </p:spPr>
+        <p:txBody>
+          <a:bodyPr wrap="square" rtlCol="0" anchor="ctr"/>
+          <a:lstStyle/>
+          <a:p>
+            <a:pPr indent="0" marL="0">
+              <a:buNone/>
+            </a:pPr>
+            <a:r>
+              <a:rPr lang="en-US" sz="1200" b="1" spc="200" kern="0" dirty="0">
+                <a:solidFill>
+                  <a:srgbClr val="0E9E8E"/>
+                </a:solidFill>
+                <a:latin typeface="Calibri" pitchFamily="34" charset="0"/>
+                <a:ea typeface="Calibri" pitchFamily="34" charset="-122"/>
+                <a:cs typeface="Calibri" pitchFamily="34" charset="-120"/>
+              </a:rPr>
+              <a:t>REAL OBSTACLES FROM THIS BUILD — EACH WITH A VERIFIABLE RECEIPT</a:t>
+            </a:r>
+            <a:endParaRPr lang="en-US" sz="1200" dirty="0"/>
+          </a:p>
+        </p:txBody>
+      </p:sp>
+      <p:sp>
+        <p:nvSpPr>
+          <p:cNvPr id="3" name="Text 1"/>
+          <p:cNvSpPr/>
+          <p:nvPr/>
+        </p:nvSpPr>
+        <p:spPr>
+          <a:xfrm>
+            <a:off x="548640" y="530352"/>
+            <a:ext cx="11064240" cy="685800"/>
+          </a:xfrm>
+          <a:prstGeom prst="rect">
+            <a:avLst/>
+          </a:prstGeom>
+          <a:noFill/>
+          <a:ln/>
+        </p:spPr>
+        <p:txBody>
+          <a:bodyPr wrap="square" rtlCol="0" anchor="ctr"/>
+          <a:lstStyle/>
+          <a:p>
+            <a:pPr indent="0" marL="0">
+              <a:buNone/>
+            </a:pPr>
+            <a:r>
+              <a:rPr lang="en-US" sz="3400" b="1" dirty="0">
+                <a:solidFill>
+                  <a:srgbClr val="0F2A47"/>
+                </a:solidFill>
+                <a:latin typeface="Cambria" pitchFamily="34" charset="0"/>
+                <a:ea typeface="Cambria" pitchFamily="34" charset="-122"/>
+                <a:cs typeface="Cambria" pitchFamily="34" charset="-120"/>
+              </a:rPr>
+              <a:t>Hard Scenarios, Handled</a:t>
+            </a:r>
+            <a:endParaRPr lang="en-US" sz="3400" dirty="0"/>
+          </a:p>
+        </p:txBody>
+      </p:sp>
+      <p:sp>
+        <p:nvSpPr>
+          <p:cNvPr id="4" name="Shape 2"/>
+          <p:cNvSpPr/>
+          <p:nvPr/>
+        </p:nvSpPr>
+        <p:spPr>
+          <a:xfrm>
+            <a:off x="548640" y="1417320"/>
+            <a:ext cx="5440680" cy="1609344"/>
+          </a:xfrm>
+          <a:prstGeom prst="roundRect">
+            <a:avLst>
+              <a:gd name="adj" fmla="val 4545"/>
+            </a:avLst>
+          </a:prstGeom>
+          <a:solidFill>
+            <a:srgbClr val="EDF5FC"/>
+          </a:solidFill>
+          <a:ln/>
+        </p:spPr>
+      </p:sp>
+      <p:sp>
+        <p:nvSpPr>
+          <p:cNvPr id="5" name="Shape 3"/>
+          <p:cNvSpPr/>
+          <p:nvPr/>
+        </p:nvSpPr>
+        <p:spPr>
+          <a:xfrm>
+            <a:off x="731520" y="1581912"/>
+            <a:ext cx="310896" cy="310896"/>
+          </a:xfrm>
+          <a:prstGeom prst="ellipse">
+            <a:avLst/>
+          </a:prstGeom>
+          <a:solidFill>
+            <a:srgbClr val="0E9E8E"/>
+          </a:solidFill>
+          <a:ln/>
+        </p:spPr>
+      </p:sp>
+      <p:sp>
+        <p:nvSpPr>
+          <p:cNvPr id="6" name="Text 4"/>
+          <p:cNvSpPr/>
+          <p:nvPr/>
+        </p:nvSpPr>
+        <p:spPr>
+          <a:xfrm>
+            <a:off x="1152144" y="1536192"/>
+            <a:ext cx="4663440" cy="365760"/>
+          </a:xfrm>
+          <a:prstGeom prst="rect">
+            <a:avLst/>
+          </a:prstGeom>
+          <a:noFill/>
+          <a:ln/>
+        </p:spPr>
+        <p:txBody>
+          <a:bodyPr wrap="square" rtlCol="0" anchor="ctr"/>
+          <a:lstStyle/>
+          <a:p>
+            <a:pPr indent="0" marL="0">
+              <a:buNone/>
+            </a:pPr>
+            <a:r>
+              <a:rPr lang="en-US" sz="1350" b="1" dirty="0">
+                <a:solidFill>
+                  <a:srgbClr val="0F2A47"/>
+                </a:solidFill>
+                <a:latin typeface="Calibri" pitchFamily="34" charset="0"/>
+                <a:ea typeface="Calibri" pitchFamily="34" charset="-122"/>
+                <a:cs typeface="Calibri" pitchFamily="34" charset="-120"/>
+              </a:rPr>
+              <a:t>Anti-bot &amp; geo walls</a:t>
+            </a:r>
+            <a:endParaRPr lang="en-US" sz="1350" dirty="0"/>
+          </a:p>
+        </p:txBody>
+      </p:sp>
+      <p:sp>
+        <p:nvSpPr>
+          <p:cNvPr id="7" name="Text 5"/>
+          <p:cNvSpPr/>
+          <p:nvPr/>
+        </p:nvSpPr>
+        <p:spPr>
+          <a:xfrm>
+            <a:off x="777240" y="1892808"/>
+            <a:ext cx="5029200" cy="1097280"/>
+          </a:xfrm>
+          <a:prstGeom prst="rect">
+            <a:avLst/>
+          </a:prstGeom>
+          <a:noFill/>
+          <a:ln/>
+        </p:spPr>
+        <p:txBody>
+          <a:bodyPr wrap="square" rtlCol="0" anchor="t"/>
+          <a:lstStyle/>
+          <a:p>
+            <a:pPr indent="0" marL="0">
+              <a:buNone/>
+            </a:pPr>
+            <a:r>
+              <a:rPr lang="en-US" sz="980" dirty="0">
+                <a:solidFill>
+                  <a:srgbClr val="24303C"/>
+                </a:solidFill>
+                <a:latin typeface="Calibri" pitchFamily="34" charset="0"/>
+                <a:ea typeface="Calibri" pitchFamily="34" charset="-122"/>
+                <a:cs typeface="Calibri" pitchFamily="34" charset="-120"/>
+              </a:rPr>
+              <a:t>SSO CloudFront rate-limits → polite backoff + real-browser fallback. Akamai TLS-fingerprinting on dfat.gov.au stayed blocked → recorded ACQUISITION_UNRESOLVED, which blocks the absence conclusion instead of faking "no treaty".</a:t>
+            </a:r>
+            <a:endParaRPr lang="en-US" sz="980" dirty="0"/>
+          </a:p>
+        </p:txBody>
+      </p:sp>
+      <p:sp>
+        <p:nvSpPr>
+          <p:cNvPr id="8" name="Shape 6"/>
+          <p:cNvSpPr/>
+          <p:nvPr/>
+        </p:nvSpPr>
+        <p:spPr>
+          <a:xfrm>
+            <a:off x="6172200" y="1417320"/>
+            <a:ext cx="5440680" cy="1609344"/>
+          </a:xfrm>
+          <a:prstGeom prst="roundRect">
+            <a:avLst>
+              <a:gd name="adj" fmla="val 4545"/>
+            </a:avLst>
+          </a:prstGeom>
+          <a:solidFill>
+            <a:srgbClr val="EDF5FC"/>
+          </a:solidFill>
+          <a:ln/>
+        </p:spPr>
+      </p:sp>
+      <p:sp>
+        <p:nvSpPr>
+          <p:cNvPr id="9" name="Shape 7"/>
+          <p:cNvSpPr/>
+          <p:nvPr/>
+        </p:nvSpPr>
+        <p:spPr>
+          <a:xfrm>
+            <a:off x="6355080" y="1581912"/>
+            <a:ext cx="310896" cy="310896"/>
+          </a:xfrm>
+          <a:prstGeom prst="ellipse">
+            <a:avLst/>
+          </a:prstGeom>
+          <a:solidFill>
+            <a:srgbClr val="D9A441"/>
+          </a:solidFill>
+          <a:ln/>
+        </p:spPr>
+      </p:sp>
+      <p:sp>
+        <p:nvSpPr>
+          <p:cNvPr id="10" name="Text 8"/>
+          <p:cNvSpPr/>
+          <p:nvPr/>
+        </p:nvSpPr>
+        <p:spPr>
+          <a:xfrm>
+            <a:off x="6775704" y="1536192"/>
+            <a:ext cx="4663440" cy="365760"/>
+          </a:xfrm>
+          <a:prstGeom prst="rect">
+            <a:avLst/>
+          </a:prstGeom>
+          <a:noFill/>
+          <a:ln/>
+        </p:spPr>
+        <p:txBody>
+          <a:bodyPr wrap="square" rtlCol="0" anchor="ctr"/>
+          <a:lstStyle/>
+          <a:p>
+            <a:pPr indent="0" marL="0">
+              <a:buNone/>
+            </a:pPr>
+            <a:r>
+              <a:rPr lang="en-US" sz="1350" b="1" dirty="0">
+                <a:solidFill>
+                  <a:srgbClr val="0F2A47"/>
+                </a:solidFill>
+                <a:latin typeface="Calibri" pitchFamily="34" charset="0"/>
+                <a:ea typeface="Calibri" pitchFamily="34" charset="-122"/>
+                <a:cs typeface="Calibri" pitchFamily="34" charset="-120"/>
+              </a:rPr>
+              <a:t>Planted gold errors</a:t>
+            </a:r>
+            <a:endParaRPr lang="en-US" sz="1350" dirty="0"/>
+          </a:p>
+        </p:txBody>
+      </p:sp>
+      <p:sp>
+        <p:nvSpPr>
+          <p:cNvPr id="11" name="Text 9"/>
+          <p:cNvSpPr/>
+          <p:nvPr/>
+        </p:nvSpPr>
+        <p:spPr>
+          <a:xfrm>
+            <a:off x="6400800" y="1892808"/>
+            <a:ext cx="5029200" cy="1097280"/>
+          </a:xfrm>
+          <a:prstGeom prst="rect">
+            <a:avLst/>
+          </a:prstGeom>
+          <a:noFill/>
+          <a:ln/>
+        </p:spPr>
+        <p:txBody>
+          <a:bodyPr wrap="square" rtlCol="0" anchor="t"/>
+          <a:lstStyle/>
+          <a:p>
+            <a:pPr indent="0" marL="0">
+              <a:buNone/>
+            </a:pPr>
+            <a:r>
+              <a:rPr lang="en-US" sz="980" dirty="0">
+                <a:solidFill>
+                  <a:srgbClr val="24303C"/>
+                </a:solidFill>
+                <a:latin typeface="Calibri" pitchFamily="34" charset="0"/>
+                <a:ea typeface="Calibri" pitchFamily="34" charset="-122"/>
+                <a:cs typeface="Calibri" pitchFamily="34" charset="-120"/>
+              </a:rPr>
+              <a:t>Malaysia sample data contains deliberate errors. Our audit caught them — including a master citation to "clause 4.11" of Act 709, which does not exist in the official text — and filed corrections with evidence.</a:t>
+            </a:r>
+            <a:endParaRPr lang="en-US" sz="980" dirty="0"/>
+          </a:p>
+        </p:txBody>
+      </p:sp>
+      <p:sp>
+        <p:nvSpPr>
+          <p:cNvPr id="12" name="Shape 10"/>
+          <p:cNvSpPr/>
+          <p:nvPr/>
+        </p:nvSpPr>
+        <p:spPr>
+          <a:xfrm>
+            <a:off x="548640" y="3172968"/>
+            <a:ext cx="5440680" cy="1609344"/>
+          </a:xfrm>
+          <a:prstGeom prst="roundRect">
+            <a:avLst>
+              <a:gd name="adj" fmla="val 4545"/>
+            </a:avLst>
+          </a:prstGeom>
+          <a:solidFill>
+            <a:srgbClr val="EDF5FC"/>
+          </a:solidFill>
+          <a:ln/>
+        </p:spPr>
+      </p:sp>
+      <p:sp>
+        <p:nvSpPr>
+          <p:cNvPr id="13" name="Shape 11"/>
+          <p:cNvSpPr/>
+          <p:nvPr/>
+        </p:nvSpPr>
+        <p:spPr>
+          <a:xfrm>
+            <a:off x="731520" y="3337560"/>
+            <a:ext cx="310896" cy="310896"/>
+          </a:xfrm>
+          <a:prstGeom prst="ellipse">
+            <a:avLst/>
+          </a:prstGeom>
+          <a:solidFill>
+            <a:srgbClr val="14548F"/>
+          </a:solidFill>
+          <a:ln/>
+        </p:spPr>
+      </p:sp>
+      <p:sp>
+        <p:nvSpPr>
+          <p:cNvPr id="14" name="Text 12"/>
+          <p:cNvSpPr/>
+          <p:nvPr/>
+        </p:nvSpPr>
+        <p:spPr>
+          <a:xfrm>
+            <a:off x="1152144" y="3291840"/>
+            <a:ext cx="4663440" cy="365760"/>
+          </a:xfrm>
+          <a:prstGeom prst="rect">
+            <a:avLst/>
+          </a:prstGeom>
+          <a:noFill/>
+          <a:ln/>
+        </p:spPr>
+        <p:txBody>
+          <a:bodyPr wrap="square" rtlCol="0" anchor="ctr"/>
+          <a:lstStyle/>
+          <a:p>
+            <a:pPr indent="0" marL="0">
+              <a:buNone/>
+            </a:pPr>
+            <a:r>
+              <a:rPr lang="en-US" sz="1350" b="1" dirty="0">
+                <a:solidFill>
+                  <a:srgbClr val="0F2A47"/>
+                </a:solidFill>
+                <a:latin typeface="Calibri" pitchFamily="34" charset="0"/>
+                <a:ea typeface="Calibri" pitchFamily="34" charset="-122"/>
+                <a:cs typeface="Calibri" pitchFamily="34" charset="-120"/>
+              </a:rPr>
+              <a:t>Monster documents</a:t>
+            </a:r>
+            <a:endParaRPr lang="en-US" sz="1350" dirty="0"/>
+          </a:p>
+        </p:txBody>
+      </p:sp>
+      <p:sp>
+        <p:nvSpPr>
+          <p:cNvPr id="15" name="Text 13"/>
+          <p:cNvSpPr/>
+          <p:nvPr/>
+        </p:nvSpPr>
+        <p:spPr>
+          <a:xfrm>
+            <a:off x="777240" y="3648456"/>
+            <a:ext cx="5029200" cy="1097280"/>
+          </a:xfrm>
+          <a:prstGeom prst="rect">
+            <a:avLst/>
+          </a:prstGeom>
+          <a:noFill/>
+          <a:ln/>
+        </p:spPr>
+        <p:txBody>
+          <a:bodyPr wrap="square" rtlCol="0" anchor="t"/>
+          <a:lstStyle/>
+          <a:p>
+            <a:pPr indent="0" marL="0">
+              <a:buNone/>
+            </a:pPr>
+            <a:r>
+              <a:rPr lang="en-US" sz="980" dirty="0">
+                <a:solidFill>
+                  <a:srgbClr val="24303C"/>
+                </a:solidFill>
+                <a:latin typeface="Calibri" pitchFamily="34" charset="0"/>
+                <a:ea typeface="Calibri" pitchFamily="34" charset="-122"/>
+                <a:cs typeface="Calibri" pitchFamily="34" charset="-120"/>
+              </a:rPr>
+              <a:t>666-page consolidated compilations, multi-volume acts (TIA = 2 PDF volumes), tables-of-contents that poison naive parsers → EPUB structure oracle + monotonic section filter + span-exact PDF alignment.</a:t>
+            </a:r>
+            <a:endParaRPr lang="en-US" sz="980" dirty="0"/>
+          </a:p>
+        </p:txBody>
+      </p:sp>
+      <p:sp>
+        <p:nvSpPr>
+          <p:cNvPr id="16" name="Shape 14"/>
+          <p:cNvSpPr/>
+          <p:nvPr/>
+        </p:nvSpPr>
+        <p:spPr>
+          <a:xfrm>
+            <a:off x="6172200" y="3172968"/>
+            <a:ext cx="5440680" cy="1609344"/>
+          </a:xfrm>
+          <a:prstGeom prst="roundRect">
+            <a:avLst>
+              <a:gd name="adj" fmla="val 4545"/>
+            </a:avLst>
+          </a:prstGeom>
+          <a:solidFill>
+            <a:srgbClr val="EDF5FC"/>
+          </a:solidFill>
+          <a:ln/>
+        </p:spPr>
+      </p:sp>
+      <p:sp>
+        <p:nvSpPr>
+          <p:cNvPr id="17" name="Shape 15"/>
+          <p:cNvSpPr/>
+          <p:nvPr/>
+        </p:nvSpPr>
+        <p:spPr>
+          <a:xfrm>
+            <a:off x="6355080" y="3337560"/>
+            <a:ext cx="310896" cy="310896"/>
+          </a:xfrm>
+          <a:prstGeom prst="ellipse">
+            <a:avLst/>
+          </a:prstGeom>
+          <a:solidFill>
+            <a:srgbClr val="0E9E8E"/>
+          </a:solidFill>
+          <a:ln/>
+        </p:spPr>
+      </p:sp>
+      <p:sp>
+        <p:nvSpPr>
+          <p:cNvPr id="18" name="Text 16"/>
+          <p:cNvSpPr/>
+          <p:nvPr/>
+        </p:nvSpPr>
+        <p:spPr>
+          <a:xfrm>
+            <a:off x="6775704" y="3291840"/>
+            <a:ext cx="4663440" cy="365760"/>
+          </a:xfrm>
+          <a:prstGeom prst="rect">
+            <a:avLst/>
+          </a:prstGeom>
+          <a:noFill/>
+          <a:ln/>
+        </p:spPr>
+        <p:txBody>
+          <a:bodyPr wrap="square" rtlCol="0" anchor="ctr"/>
+          <a:lstStyle/>
+          <a:p>
+            <a:pPr indent="0" marL="0">
+              <a:buNone/>
+            </a:pPr>
+            <a:r>
+              <a:rPr lang="en-US" sz="1350" b="1" dirty="0">
+                <a:solidFill>
+                  <a:srgbClr val="0F2A47"/>
+                </a:solidFill>
+                <a:latin typeface="Calibri" pitchFamily="34" charset="0"/>
+                <a:ea typeface="Calibri" pitchFamily="34" charset="-122"/>
+                <a:cs typeface="Calibri" pitchFamily="34" charset="-120"/>
+              </a:rPr>
+              <a:t>Scanned &amp; bilingual</a:t>
+            </a:r>
+            <a:endParaRPr lang="en-US" sz="1350" dirty="0"/>
+          </a:p>
+        </p:txBody>
+      </p:sp>
+      <p:sp>
+        <p:nvSpPr>
+          <p:cNvPr id="19" name="Text 17"/>
+          <p:cNvSpPr/>
+          <p:nvPr/>
+        </p:nvSpPr>
+        <p:spPr>
+          <a:xfrm>
+            <a:off x="6400800" y="3648456"/>
+            <a:ext cx="5029200" cy="1097280"/>
+          </a:xfrm>
+          <a:prstGeom prst="rect">
+            <a:avLst/>
+          </a:prstGeom>
+          <a:noFill/>
+          <a:ln/>
+        </p:spPr>
+        <p:txBody>
+          <a:bodyPr wrap="square" rtlCol="0" anchor="t"/>
+          <a:lstStyle/>
+          <a:p>
+            <a:pPr indent="0" marL="0">
+              <a:buNone/>
+            </a:pPr>
+            <a:r>
+              <a:rPr lang="en-US" sz="980" dirty="0">
+                <a:solidFill>
+                  <a:srgbClr val="24303C"/>
+                </a:solidFill>
+                <a:latin typeface="Calibri" pitchFamily="34" charset="0"/>
+                <a:ea typeface="Calibri" pitchFamily="34" charset="-122"/>
+                <a:cs typeface="Calibri" pitchFamily="34" charset="-120"/>
+              </a:rPr>
+              <a:t>Gazette scans go through OCR with per-page confidence and glyph repair (a misread "12a" is restored from statutory sequence); Malay-primary acts parse via the "Seksyen/Perkara" grammar profile with original-language verbatim text.</a:t>
+            </a:r>
+            <a:endParaRPr lang="en-US" sz="980" dirty="0"/>
+          </a:p>
+        </p:txBody>
+      </p:sp>
+      <p:sp>
+        <p:nvSpPr>
+          <p:cNvPr id="20" name="Shape 18"/>
+          <p:cNvSpPr/>
+          <p:nvPr/>
+        </p:nvSpPr>
+        <p:spPr>
+          <a:xfrm>
+            <a:off x="548640" y="4928616"/>
+            <a:ext cx="5440680" cy="1609344"/>
+          </a:xfrm>
+          <a:prstGeom prst="roundRect">
+            <a:avLst>
+              <a:gd name="adj" fmla="val 4545"/>
+            </a:avLst>
+          </a:prstGeom>
+          <a:solidFill>
+            <a:srgbClr val="EDF5FC"/>
+          </a:solidFill>
+          <a:ln/>
+        </p:spPr>
+      </p:sp>
+      <p:sp>
+        <p:nvSpPr>
+          <p:cNvPr id="21" name="Shape 19"/>
+          <p:cNvSpPr/>
+          <p:nvPr/>
+        </p:nvSpPr>
+        <p:spPr>
+          <a:xfrm>
+            <a:off x="731520" y="5093208"/>
+            <a:ext cx="310896" cy="310896"/>
+          </a:xfrm>
+          <a:prstGeom prst="ellipse">
+            <a:avLst/>
+          </a:prstGeom>
+          <a:solidFill>
+            <a:srgbClr val="D9A441"/>
+          </a:solidFill>
+          <a:ln/>
+        </p:spPr>
+      </p:sp>
+      <p:sp>
+        <p:nvSpPr>
+          <p:cNvPr id="22" name="Text 20"/>
+          <p:cNvSpPr/>
+          <p:nvPr/>
+        </p:nvSpPr>
+        <p:spPr>
+          <a:xfrm>
+            <a:off x="1152144" y="5047488"/>
+            <a:ext cx="4663440" cy="365760"/>
+          </a:xfrm>
+          <a:prstGeom prst="rect">
+            <a:avLst/>
+          </a:prstGeom>
+          <a:noFill/>
+          <a:ln/>
+        </p:spPr>
+        <p:txBody>
+          <a:bodyPr wrap="square" rtlCol="0" anchor="ctr"/>
+          <a:lstStyle/>
+          <a:p>
+            <a:pPr indent="0" marL="0">
+              <a:buNone/>
+            </a:pPr>
+            <a:r>
+              <a:rPr lang="en-US" sz="1350" b="1" dirty="0">
+                <a:solidFill>
+                  <a:srgbClr val="0F2A47"/>
+                </a:solidFill>
+                <a:latin typeface="Calibri" pitchFamily="34" charset="0"/>
+                <a:ea typeface="Calibri" pitchFamily="34" charset="-122"/>
+                <a:cs typeface="Calibri" pitchFamily="34" charset="-120"/>
+              </a:rPr>
+              <a:t>Polarity traps</a:t>
+            </a:r>
+            <a:endParaRPr lang="en-US" sz="1350" dirty="0"/>
+          </a:p>
+        </p:txBody>
+      </p:sp>
+      <p:sp>
+        <p:nvSpPr>
+          <p:cNvPr id="23" name="Text 21"/>
+          <p:cNvSpPr/>
+          <p:nvPr/>
+        </p:nvSpPr>
+        <p:spPr>
+          <a:xfrm>
+            <a:off x="777240" y="5404104"/>
+            <a:ext cx="5029200" cy="1097280"/>
+          </a:xfrm>
+          <a:prstGeom prst="rect">
+            <a:avLst/>
+          </a:prstGeom>
+          <a:noFill/>
+          <a:ln/>
+        </p:spPr>
+        <p:txBody>
+          <a:bodyPr wrap="square" rtlCol="0" anchor="t"/>
+          <a:lstStyle/>
+          <a:p>
+            <a:pPr indent="0" marL="0">
+              <a:buNone/>
+            </a:pPr>
+            <a:r>
+              <a:rPr lang="en-US" sz="980" dirty="0">
+                <a:solidFill>
+                  <a:srgbClr val="24303C"/>
+                </a:solidFill>
+                <a:latin typeface="Calibri" pitchFamily="34" charset="0"/>
+                <a:ea typeface="Calibri" pitchFamily="34" charset="-122"/>
+                <a:cs typeface="Calibri" pitchFamily="34" charset="-120"/>
+              </a:rPr>
+              <a:t>7.1/7.2 and 6.5 score the ABSENCE of frameworks. Our first treaty sweep proved the danger: 77 relevant articles retrieved, 0 mapped — the LLM rejected them for proving the "wrong" polarity. One rubric-data line fixed it; a regression test pins it.</a:t>
+            </a:r>
+            <a:endParaRPr lang="en-US" sz="980" dirty="0"/>
+          </a:p>
+        </p:txBody>
+      </p:sp>
+      <p:sp>
+        <p:nvSpPr>
+          <p:cNvPr id="24" name="Shape 22"/>
+          <p:cNvSpPr/>
+          <p:nvPr/>
+        </p:nvSpPr>
+        <p:spPr>
+          <a:xfrm>
+            <a:off x="6172200" y="4928616"/>
+            <a:ext cx="5440680" cy="1609344"/>
+          </a:xfrm>
+          <a:prstGeom prst="roundRect">
+            <a:avLst>
+              <a:gd name="adj" fmla="val 4545"/>
+            </a:avLst>
+          </a:prstGeom>
+          <a:solidFill>
+            <a:srgbClr val="EDF5FC"/>
+          </a:solidFill>
+          <a:ln/>
+        </p:spPr>
+      </p:sp>
+      <p:sp>
+        <p:nvSpPr>
+          <p:cNvPr id="25" name="Shape 23"/>
+          <p:cNvSpPr/>
+          <p:nvPr/>
+        </p:nvSpPr>
+        <p:spPr>
+          <a:xfrm>
+            <a:off x="6355080" y="5093208"/>
+            <a:ext cx="310896" cy="310896"/>
+          </a:xfrm>
+          <a:prstGeom prst="ellipse">
+            <a:avLst/>
+          </a:prstGeom>
+          <a:solidFill>
+            <a:srgbClr val="14548F"/>
+          </a:solidFill>
+          <a:ln/>
+        </p:spPr>
+      </p:sp>
+      <p:sp>
+        <p:nvSpPr>
+          <p:cNvPr id="26" name="Text 24"/>
+          <p:cNvSpPr/>
+          <p:nvPr/>
+        </p:nvSpPr>
+        <p:spPr>
+          <a:xfrm>
+            <a:off x="6775704" y="5047488"/>
+            <a:ext cx="4663440" cy="365760"/>
+          </a:xfrm>
+          <a:prstGeom prst="rect">
+            <a:avLst/>
+          </a:prstGeom>
+          <a:noFill/>
+          <a:ln/>
+        </p:spPr>
+        <p:txBody>
+          <a:bodyPr wrap="square" rtlCol="0" anchor="ctr"/>
+          <a:lstStyle/>
+          <a:p>
+            <a:pPr indent="0" marL="0">
+              <a:buNone/>
+            </a:pPr>
+            <a:r>
+              <a:rPr lang="en-US" sz="1350" b="1" dirty="0">
+                <a:solidFill>
+                  <a:srgbClr val="0F2A47"/>
+                </a:solidFill>
+                <a:latin typeface="Calibri" pitchFamily="34" charset="0"/>
+                <a:ea typeface="Calibri" pitchFamily="34" charset="-122"/>
+                <a:cs typeface="Calibri" pitchFamily="34" charset="-120"/>
+              </a:rPr>
+              <a:t>Mid-clause quotes</a:t>
+            </a:r>
+            <a:endParaRPr lang="en-US" sz="1350" dirty="0"/>
+          </a:p>
+        </p:txBody>
+      </p:sp>
+      <p:sp>
+        <p:nvSpPr>
+          <p:cNvPr id="27" name="Text 25"/>
+          <p:cNvSpPr/>
+          <p:nvPr/>
+        </p:nvSpPr>
+        <p:spPr>
+          <a:xfrm>
+            <a:off x="6400800" y="5404104"/>
+            <a:ext cx="5029200" cy="1097280"/>
+          </a:xfrm>
+          <a:prstGeom prst="rect">
+            <a:avLst/>
+          </a:prstGeom>
+          <a:noFill/>
+          <a:ln/>
+        </p:spPr>
+        <p:txBody>
+          <a:bodyPr wrap="square" rtlCol="0" anchor="t"/>
+          <a:lstStyle/>
+          <a:p>
+            <a:pPr indent="0" marL="0">
+              <a:buNone/>
+            </a:pPr>
+            <a:r>
+              <a:rPr lang="en-US" sz="980" dirty="0">
+                <a:solidFill>
+                  <a:srgbClr val="24303C"/>
+                </a:solidFill>
+                <a:latin typeface="Calibri" pitchFamily="34" charset="0"/>
+                <a:ea typeface="Calibri" pitchFamily="34" charset="-122"/>
+                <a:cs typeface="Calibri" pitchFamily="34" charset="-120"/>
+              </a:rPr>
+              <a:t>A quote that ends "…issued with an or" is an embarrassment in front of a lawyer. Snippets are finalized source-exact and structurally closed (through list children to a genuine sentence stop) BEFORE gating; unprovable closures cannot export.</a:t>
+            </a:r>
+            <a:endParaRPr lang="en-US" sz="980" dirty="0"/>
+          </a:p>
+        </p:txBody>
+      </p:sp>
+    </p:spTree>
+  </p:cSld>
+  <p:clrMapOvr>
+    <a:masterClrMapping/>
+  </p:clrMapOvr>
+</p:sld>
+</file>
+
+<file path=ppt/slides/slide14.xml><?xml version="1.0" encoding="utf-8"?>
+<p:sld xmlns:a="http://schemas.openxmlformats.org/drawingml/2006/main" xmlns:r="http://schemas.openxmlformats.org/officeDocument/2006/relationships" xmlns:p="http://schemas.openxmlformats.org/presentationml/2006/main">
+  <p:cSld name="Slide 14">
+    <p:bg>
+      <p:bgPr>
+        <a:solidFill>
+          <a:srgbClr val="FFFFFF"/>
+        </a:solidFill>
+      </p:bgPr>
+    </p:bg>
+    <p:spTree>
+      <p:nvGrpSpPr>
+        <p:cNvPr id="1" name=""/>
+        <p:cNvGrpSpPr/>
+        <p:nvPr/>
+      </p:nvGrpSpPr>
+      <p:grpSpPr>
+        <a:xfrm>
+          <a:off x="0" y="0"/>
+          <a:ext cx="0" cy="0"/>
+          <a:chOff x="0" y="0"/>
+          <a:chExt cx="0" cy="0"/>
+        </a:xfrm>
+      </p:grpSpPr>
+      <p:sp>
+        <p:nvSpPr>
+          <p:cNvPr id="2" name="Text 0"/>
+          <p:cNvSpPr/>
+          <p:nvPr/>
+        </p:nvSpPr>
+        <p:spPr>
+          <a:xfrm>
+            <a:off x="548640" y="292608"/>
+            <a:ext cx="11064240" cy="292608"/>
+          </a:xfrm>
+          <a:prstGeom prst="rect">
+            <a:avLst/>
+          </a:prstGeom>
+          <a:noFill/>
+          <a:ln/>
+        </p:spPr>
+        <p:txBody>
+          <a:bodyPr wrap="square" rtlCol="0" anchor="ctr"/>
+          <a:lstStyle/>
+          <a:p>
+            <a:pPr indent="0" marL="0">
+              <a:buNone/>
+            </a:pPr>
+            <a:r>
+              <a:rPr lang="en-US" sz="1200" b="1" spc="200" kern="0" dirty="0">
+                <a:solidFill>
+                  <a:srgbClr val="0E9E8E"/>
+                </a:solidFill>
+                <a:latin typeface="Calibri" pitchFamily="34" charset="0"/>
+                <a:ea typeface="Calibri" pitchFamily="34" charset="-122"/>
+                <a:cs typeface="Calibri" pitchFamily="34" charset="-120"/>
+              </a:rPr>
+              <a:t>THE FINALS QUESTION, ANSWERED CONCRETELY</a:t>
+            </a:r>
+            <a:endParaRPr lang="en-US" sz="1200" dirty="0"/>
+          </a:p>
+        </p:txBody>
+      </p:sp>
+      <p:sp>
+        <p:nvSpPr>
+          <p:cNvPr id="3" name="Text 1"/>
+          <p:cNvSpPr/>
+          <p:nvPr/>
+        </p:nvSpPr>
+        <p:spPr>
+          <a:xfrm>
+            <a:off x="548640" y="530352"/>
+            <a:ext cx="11064240" cy="685800"/>
+          </a:xfrm>
+          <a:prstGeom prst="rect">
+            <a:avLst/>
+          </a:prstGeom>
+          <a:noFill/>
+          <a:ln/>
+        </p:spPr>
+        <p:txBody>
+          <a:bodyPr wrap="square" rtlCol="0" anchor="ctr"/>
+          <a:lstStyle/>
+          <a:p>
+            <a:pPr indent="0" marL="0">
+              <a:buNone/>
+            </a:pPr>
+            <a:r>
+              <a:rPr lang="en-US" sz="3400" b="1" dirty="0">
+                <a:solidFill>
+                  <a:srgbClr val="0F2A47"/>
+                </a:solidFill>
+                <a:latin typeface="Cambria" pitchFamily="34" charset="0"/>
+                <a:ea typeface="Cambria" pitchFamily="34" charset="-122"/>
+                <a:cs typeface="Cambria" pitchFamily="34" charset="-120"/>
+              </a:rPr>
+              <a:t>Adding an Economy Is a Data Change</a:t>
+            </a:r>
+            <a:endParaRPr lang="en-US" sz="3400" dirty="0"/>
+          </a:p>
+        </p:txBody>
+      </p:sp>
+      <p:sp>
+        <p:nvSpPr>
+          <p:cNvPr id="4" name="Shape 2"/>
+          <p:cNvSpPr/>
+          <p:nvPr/>
+        </p:nvSpPr>
+        <p:spPr>
+          <a:xfrm>
+            <a:off x="548640" y="1417320"/>
+            <a:ext cx="5989320" cy="4846320"/>
+          </a:xfrm>
+          <a:prstGeom prst="roundRect">
+            <a:avLst>
+              <a:gd name="adj" fmla="val 1509"/>
+            </a:avLst>
+          </a:prstGeom>
+          <a:solidFill>
+            <a:srgbClr val="10253E"/>
+          </a:solidFill>
+          <a:ln/>
+        </p:spPr>
+      </p:sp>
+      <p:sp>
+        <p:nvSpPr>
+          <p:cNvPr id="5" name="Text 3"/>
+          <p:cNvSpPr/>
+          <p:nvPr/>
+        </p:nvSpPr>
+        <p:spPr>
+          <a:xfrm>
+            <a:off x="822960" y="1600200"/>
+            <a:ext cx="5394960" cy="320040"/>
+          </a:xfrm>
+          <a:prstGeom prst="rect">
+            <a:avLst/>
+          </a:prstGeom>
+          <a:noFill/>
+          <a:ln/>
+        </p:spPr>
+        <p:txBody>
+          <a:bodyPr wrap="square" rtlCol="0" anchor="ctr"/>
+          <a:lstStyle/>
+          <a:p>
+            <a:pPr indent="0" marL="0">
+              <a:buNone/>
+            </a:pPr>
+            <a:r>
+              <a:rPr lang="en-US" sz="1200" b="1" dirty="0">
+                <a:solidFill>
+                  <a:srgbClr val="0E9E8E"/>
+                </a:solidFill>
+                <a:latin typeface="Calibri" pitchFamily="34" charset="0"/>
+                <a:ea typeface="Calibri" pitchFamily="34" charset="-122"/>
+                <a:cs typeface="Calibri" pitchFamily="34" charset="-120"/>
+              </a:rPr>
+              <a:t>configs/jurisdictions/th.yaml  (all it takes)</a:t>
+            </a:r>
+            <a:endParaRPr lang="en-US" sz="1200" dirty="0"/>
+          </a:p>
+        </p:txBody>
+      </p:sp>
+      <p:sp>
+        <p:nvSpPr>
+          <p:cNvPr id="6" name="Text 4"/>
+          <p:cNvSpPr/>
+          <p:nvPr/>
+        </p:nvSpPr>
+        <p:spPr>
+          <a:xfrm>
+            <a:off x="822960" y="1965960"/>
+            <a:ext cx="5440680" cy="4114800"/>
+          </a:xfrm>
+          <a:prstGeom prst="rect">
+            <a:avLst/>
+          </a:prstGeom>
+          <a:noFill/>
+          <a:ln/>
+        </p:spPr>
+        <p:txBody>
+          <a:bodyPr wrap="square" rtlCol="0" anchor="t"/>
+          <a:lstStyle/>
+          <a:p>
+            <a:pPr indent="0" marL="0">
+              <a:buNone/>
+            </a:pPr>
+            <a:r>
+              <a:rPr lang="en-US" sz="1100" dirty="0">
+                <a:solidFill>
+                  <a:srgbClr val="D9E6F2"/>
+                </a:solidFill>
+                <a:latin typeface="Courier New" pitchFamily="34" charset="0"/>
+                <a:ea typeface="Courier New" pitchFamily="34" charset="-122"/>
+                <a:cs typeface="Courier New" pitchFamily="34" charset="-120"/>
+              </a:rPr>
+              <a:t>jurisdiction: TH</a:t>
+            </a:r>
+            <a:endParaRPr lang="en-US" sz="1100" dirty="0"/>
+          </a:p>
+          <a:p>
+            <a:pPr indent="0" marL="0">
+              <a:buNone/>
+            </a:pPr>
+            <a:r>
+              <a:rPr lang="en-US" sz="1100" dirty="0">
+                <a:solidFill>
+                  <a:srgbClr val="D9E6F2"/>
+                </a:solidFill>
+                <a:latin typeface="Courier New" pitchFamily="34" charset="0"/>
+                <a:ea typeface="Courier New" pitchFamily="34" charset="-122"/>
+                <a:cs typeface="Courier New" pitchFamily="34" charset="-120"/>
+              </a:rPr>
+              <a:t>source_format: pdf</a:t>
+            </a:r>
+            <a:endParaRPr lang="en-US" sz="1100" dirty="0"/>
+          </a:p>
+          <a:p>
+            <a:pPr indent="0" marL="0">
+              <a:buNone/>
+            </a:pPr>
+            <a:r>
+              <a:rPr lang="en-US" sz="1100" dirty="0">
+                <a:solidFill>
+                  <a:srgbClr val="D9E6F2"/>
+                </a:solidFill>
+                <a:latin typeface="Courier New" pitchFamily="34" charset="0"/>
+                <a:ea typeface="Courier New" pitchFamily="34" charset="-122"/>
+                <a:cs typeface="Courier New" pitchFamily="34" charset="-120"/>
+              </a:rPr>
+              <a:t>languages: { primary: th, supported: [th, en] }</a:t>
+            </a:r>
+            <a:endParaRPr lang="en-US" sz="1100" dirty="0"/>
+          </a:p>
+          <a:p>
+            <a:pPr indent="0" marL="0">
+              <a:buNone/>
+            </a:pPr>
+            <a:r>
+              <a:rPr lang="en-US" sz="1100" dirty="0">
+                <a:solidFill>
+                  <a:srgbClr val="D9E6F2"/>
+                </a:solidFill>
+                <a:latin typeface="Courier New" pitchFamily="34" charset="0"/>
+                <a:ea typeface="Courier New" pitchFamily="34" charset="-122"/>
+                <a:cs typeface="Courier New" pitchFamily="34" charset="-120"/>
+              </a:rPr>
+              <a:t>section_grammars: [thai]          # "มาตรา N" — named profile</a:t>
+            </a:r>
+            <a:endParaRPr lang="en-US" sz="1100" dirty="0"/>
+          </a:p>
+          <a:p>
+            <a:pPr indent="0" marL="0">
+              <a:buNone/>
+            </a:pPr>
+            <a:r>
+              <a:rPr lang="en-US" sz="1100" dirty="0">
+                <a:solidFill>
+                  <a:srgbClr val="D9E6F2"/>
+                </a:solidFill>
+                <a:latin typeface="Courier New" pitchFamily="34" charset="0"/>
+                <a:ea typeface="Courier New" pitchFamily="34" charset="-122"/>
+                <a:cs typeface="Courier New" pitchFamily="34" charset="-120"/>
+              </a:rPr>
+              <a:t>official_sources:</a:t>
+            </a:r>
+            <a:endParaRPr lang="en-US" sz="1100" dirty="0"/>
+          </a:p>
+          <a:p>
+            <a:pPr indent="0" marL="0">
+              <a:buNone/>
+            </a:pPr>
+            <a:r>
+              <a:rPr lang="en-US" sz="1100" dirty="0">
+                <a:solidFill>
+                  <a:srgbClr val="D9E6F2"/>
+                </a:solidFill>
+                <a:latin typeface="Courier New" pitchFamily="34" charset="0"/>
+                <a:ea typeface="Courier New" pitchFamily="34" charset="-122"/>
+                <a:cs typeface="Courier New" pitchFamily="34" charset="-120"/>
+              </a:rPr>
+              <a:t>  - { domain: ratchakitcha.soc.go.th,</a:t>
+            </a:r>
+            <a:endParaRPr lang="en-US" sz="1100" dirty="0"/>
+          </a:p>
+          <a:p>
+            <a:pPr indent="0" marL="0">
+              <a:buNone/>
+            </a:pPr>
+            <a:r>
+              <a:rPr lang="en-US" sz="1100" dirty="0">
+                <a:solidFill>
+                  <a:srgbClr val="D9E6F2"/>
+                </a:solidFill>
+                <a:latin typeface="Courier New" pitchFamily="34" charset="0"/>
+                <a:ea typeface="Courier New" pitchFamily="34" charset="-122"/>
+                <a:cs typeface="Courier New" pitchFamily="34" charset="-120"/>
+              </a:rPr>
+              <a:t>      source_type: official_gazette }</a:t>
+            </a:r>
+            <a:endParaRPr lang="en-US" sz="1100" dirty="0"/>
+          </a:p>
+          <a:p>
+            <a:pPr indent="0" marL="0">
+              <a:buNone/>
+            </a:pPr>
+            <a:r>
+              <a:rPr lang="en-US" sz="1100" dirty="0">
+                <a:solidFill>
+                  <a:srgbClr val="D9E6F2"/>
+                </a:solidFill>
+                <a:latin typeface="Courier New" pitchFamily="34" charset="0"/>
+                <a:ea typeface="Courier New" pitchFamily="34" charset="-122"/>
+                <a:cs typeface="Courier New" pitchFamily="34" charset="-120"/>
+              </a:rPr>
+              <a:t>citation_patterns:</a:t>
+            </a:r>
+            <a:endParaRPr lang="en-US" sz="1100" dirty="0"/>
+          </a:p>
+          <a:p>
+            <a:pPr indent="0" marL="0">
+              <a:buNone/>
+            </a:pPr>
+            <a:r>
+              <a:rPr lang="en-US" sz="1100" dirty="0">
+                <a:solidFill>
+                  <a:srgbClr val="D9E6F2"/>
+                </a:solidFill>
+                <a:latin typeface="Courier New" pitchFamily="34" charset="0"/>
+                <a:ea typeface="Courier New" pitchFamily="34" charset="-122"/>
+                <a:cs typeface="Courier New" pitchFamily="34" charset="-120"/>
+              </a:rPr>
+              <a:t>  section: ["s. {n}", "มาตรา {n}"]</a:t>
+            </a:r>
+            <a:endParaRPr lang="en-US" sz="1100" dirty="0"/>
+          </a:p>
+          <a:p>
+            <a:pPr indent="0" marL="0">
+              <a:buNone/>
+            </a:pPr>
+            <a:r>
+              <a:rPr lang="en-US" sz="1100" dirty="0">
+                <a:solidFill>
+                  <a:srgbClr val="D9E6F2"/>
+                </a:solidFill>
+                <a:latin typeface="Courier New" pitchFamily="34" charset="0"/>
+                <a:ea typeface="Courier New" pitchFamily="34" charset="-122"/>
+                <a:cs typeface="Courier New" pitchFamily="34" charset="-120"/>
+              </a:rPr>
+              <a:t>status_assertions:</a:t>
+            </a:r>
+            <a:endParaRPr lang="en-US" sz="1100" dirty="0"/>
+          </a:p>
+          <a:p>
+            <a:pPr indent="0" marL="0">
+              <a:buNone/>
+            </a:pPr>
+            <a:r>
+              <a:rPr lang="en-US" sz="1100" dirty="0">
+                <a:solidFill>
+                  <a:srgbClr val="D9E6F2"/>
+                </a:solidFill>
+                <a:latin typeface="Courier New" pitchFamily="34" charset="0"/>
+                <a:ea typeface="Courier New" pitchFamily="34" charset="-122"/>
+                <a:cs typeface="Courier New" pitchFamily="34" charset="-120"/>
+              </a:rPr>
+              <a:t>  "PDPA B.E. 2562": { status: in_force, fact_url: "…" }</a:t>
+            </a:r>
+            <a:endParaRPr lang="en-US" sz="1100" dirty="0"/>
+          </a:p>
+          <a:p>
+            <a:pPr indent="0" marL="0">
+              <a:buNone/>
+            </a:pPr>
+            <a:endParaRPr lang="en-US" sz="1100" dirty="0"/>
+          </a:p>
+          <a:p>
+            <a:pPr indent="0" marL="0">
+              <a:buNone/>
+            </a:pPr>
+            <a:r>
+              <a:rPr lang="en-US" sz="1100" dirty="0">
+                <a:solidFill>
+                  <a:srgbClr val="D9E6F2"/>
+                </a:solidFill>
+                <a:latin typeface="Courier New" pitchFamily="34" charset="0"/>
+                <a:ea typeface="Courier New" pitchFamily="34" charset="-122"/>
+                <a:cs typeface="Courier New" pitchFamily="34" charset="-120"/>
+              </a:rPr>
+              <a:t># + seed rows in data/seeds.json  (official URLs)</a:t>
+            </a:r>
+            <a:endParaRPr lang="en-US" sz="1100" dirty="0"/>
+          </a:p>
+          <a:p>
+            <a:pPr indent="0" marL="0">
+              <a:buNone/>
+            </a:pPr>
+            <a:r>
+              <a:rPr lang="en-US" sz="1100" dirty="0">
+                <a:solidFill>
+                  <a:srgbClr val="D9E6F2"/>
+                </a:solidFill>
+                <a:latin typeface="Courier New" pitchFamily="34" charset="0"/>
+                <a:ea typeface="Courier New" pitchFamily="34" charset="-122"/>
+                <a:cs typeface="Courier New" pitchFamily="34" charset="-120"/>
+              </a:rPr>
+              <a:t># + nothing else. No code.</a:t>
+            </a:r>
+            <a:endParaRPr lang="en-US" sz="1100" dirty="0"/>
+          </a:p>
+        </p:txBody>
+      </p:sp>
+      <p:sp>
+        <p:nvSpPr>
+          <p:cNvPr id="7" name="Shape 5"/>
+          <p:cNvSpPr/>
+          <p:nvPr/>
+        </p:nvSpPr>
+        <p:spPr>
+          <a:xfrm>
+            <a:off x="6720840" y="1417320"/>
+            <a:ext cx="4892040" cy="4846320"/>
+          </a:xfrm>
+          <a:prstGeom prst="roundRect">
+            <a:avLst>
+              <a:gd name="adj" fmla="val 1509"/>
+            </a:avLst>
+          </a:prstGeom>
+          <a:solidFill>
+            <a:srgbClr val="EDF5FC"/>
+          </a:solidFill>
+          <a:ln/>
+        </p:spPr>
+      </p:sp>
+      <p:sp>
+        <p:nvSpPr>
+          <p:cNvPr id="8" name="Text 6"/>
+          <p:cNvSpPr/>
+          <p:nvPr/>
+        </p:nvSpPr>
+        <p:spPr>
+          <a:xfrm>
+            <a:off x="6995160" y="1600200"/>
+            <a:ext cx="4389120" cy="320040"/>
+          </a:xfrm>
+          <a:prstGeom prst="rect">
+            <a:avLst/>
+          </a:prstGeom>
+          <a:noFill/>
+          <a:ln/>
+        </p:spPr>
+        <p:txBody>
+          <a:bodyPr wrap="square" rtlCol="0" anchor="ctr"/>
+          <a:lstStyle/>
+          <a:p>
+            <a:pPr indent="0" marL="0">
+              <a:buNone/>
+            </a:pPr>
+            <a:r>
+              <a:rPr lang="en-US" sz="1300" b="1" spc="100" kern="0" dirty="0">
+                <a:solidFill>
+                  <a:srgbClr val="0E9E8E"/>
+                </a:solidFill>
+                <a:latin typeface="Calibri" pitchFamily="34" charset="0"/>
+                <a:ea typeface="Calibri" pitchFamily="34" charset="-122"/>
+                <a:cs typeface="Calibri" pitchFamily="34" charset="-120"/>
+              </a:rPr>
+              <a:t>WHY IT SCALES</a:t>
+            </a:r>
+            <a:endParaRPr lang="en-US" sz="1300" dirty="0"/>
+          </a:p>
+        </p:txBody>
+      </p:sp>
+      <p:sp>
+        <p:nvSpPr>
+          <p:cNvPr id="9" name="Text 7"/>
+          <p:cNvSpPr/>
+          <p:nvPr/>
+        </p:nvSpPr>
+        <p:spPr>
+          <a:xfrm>
+            <a:off x="6995160" y="1965960"/>
+            <a:ext cx="4389120" cy="4114800"/>
+          </a:xfrm>
+          <a:prstGeom prst="rect">
+            <a:avLst/>
+          </a:prstGeom>
+          <a:noFill/>
+          <a:ln/>
+        </p:spPr>
+        <p:txBody>
+          <a:bodyPr wrap="square" rtlCol="0" anchor="t"/>
+          <a:lstStyle/>
+          <a:p>
+            <a:pPr marL="342900" indent="-342900">
+              <a:spcAft>
+                <a:spcPts val="800"/>
+              </a:spcAft>
+              <a:buSzPct val="100000"/>
+              <a:buChar char="•"/>
+            </a:pPr>
+            <a:r>
+              <a:rPr lang="en-US" sz="1100" dirty="0">
+                <a:solidFill>
+                  <a:srgbClr val="24303C"/>
+                </a:solidFill>
+                <a:latin typeface="Calibri" pitchFamily="34" charset="0"/>
+                <a:ea typeface="Calibri" pitchFamily="34" charset="-122"/>
+                <a:cs typeface="Calibri" pitchFamily="34" charset="-120"/>
+              </a:rPr>
+              <a:t>Extractors are format-based (HTML / PDF / EPUB / OCR), never country-based — a new economy reuses them untouched.</a:t>
+            </a:r>
+            <a:endParaRPr lang="en-US" sz="1100" dirty="0"/>
+          </a:p>
+          <a:p>
+            <a:pPr marL="342900" indent="-342900">
+              <a:spcAft>
+                <a:spcPts val="800"/>
+              </a:spcAft>
+              <a:buSzPct val="100000"/>
+              <a:buChar char="•"/>
+            </a:pPr>
+            <a:r>
+              <a:rPr lang="en-US" sz="1100" dirty="0">
+                <a:solidFill>
+                  <a:srgbClr val="24303C"/>
+                </a:solidFill>
+                <a:latin typeface="Calibri" pitchFamily="34" charset="0"/>
+                <a:ea typeface="Calibri" pitchFamily="34" charset="-122"/>
+                <a:cs typeface="Calibri" pitchFamily="34" charset="-120"/>
+              </a:rPr>
+              <a:t>Section grammars are named data profiles: treaty and Malay shipped this round; "Pasal", "Статья", "มาตรา" are one dictionary entry each.</a:t>
+            </a:r>
+            <a:endParaRPr lang="en-US" sz="1100" dirty="0"/>
+          </a:p>
+          <a:p>
+            <a:pPr marL="342900" indent="-342900">
+              <a:spcAft>
+                <a:spcPts val="800"/>
+              </a:spcAft>
+              <a:buSzPct val="100000"/>
+              <a:buChar char="•"/>
+            </a:pPr>
+            <a:r>
+              <a:rPr lang="en-US" sz="1100" dirty="0">
+                <a:solidFill>
+                  <a:srgbClr val="24303C"/>
+                </a:solidFill>
+                <a:latin typeface="Calibri" pitchFamily="34" charset="0"/>
+                <a:ea typeface="Calibri" pitchFamily="34" charset="-122"/>
+                <a:cs typeface="Calibri" pitchFamily="34" charset="-120"/>
+              </a:rPr>
+              <a:t>Rubric YAML is economy-independent — pillars are added the same way (P8 = one new YAML, zero engine changes).</a:t>
+            </a:r>
+            <a:endParaRPr lang="en-US" sz="1100" dirty="0"/>
+          </a:p>
+          <a:p>
+            <a:pPr marL="342900" indent="-342900">
+              <a:spcAft>
+                <a:spcPts val="800"/>
+              </a:spcAft>
+              <a:buSzPct val="100000"/>
+              <a:buChar char="•"/>
+            </a:pPr>
+            <a:r>
+              <a:rPr lang="en-US" sz="1100" dirty="0">
+                <a:solidFill>
+                  <a:srgbClr val="24303C"/>
+                </a:solidFill>
+                <a:latin typeface="Calibri" pitchFamily="34" charset="0"/>
+                <a:ea typeface="Calibri" pitchFamily="34" charset="-122"/>
+                <a:cs typeface="Calibri" pitchFamily="34" charset="-120"/>
+              </a:rPr>
+              <a:t>Cross-lingual retrieval (BGE-M3) + original-language verbatim + English column are already wired.</a:t>
+            </a:r>
+            <a:endParaRPr lang="en-US" sz="1100" dirty="0"/>
+          </a:p>
+          <a:p>
+            <a:pPr marL="342900" indent="-342900">
+              <a:spcAft>
+                <a:spcPts val="800"/>
+              </a:spcAft>
+              <a:buSzPct val="100000"/>
+              <a:buChar char="•"/>
+            </a:pPr>
+            <a:r>
+              <a:rPr lang="en-US" sz="1100" dirty="0">
+                <a:solidFill>
+                  <a:srgbClr val="24303C"/>
+                </a:solidFill>
+                <a:latin typeface="Calibri" pitchFamily="34" charset="0"/>
+                <a:ea typeface="Calibri" pitchFamily="34" charset="-122"/>
+                <a:cs typeface="Calibri" pitchFamily="34" charset="-120"/>
+              </a:rPr>
+              <a:t>Proof: this round, treaties + subsidiary legislation + Malay grammar were added mid-sprint as configuration — the engine diff was generic plumbing only.</a:t>
+            </a:r>
+            <a:endParaRPr lang="en-US" sz="1100" dirty="0"/>
+          </a:p>
+          <a:p>
+            <a:pPr marL="342900" indent="-342900">
+              <a:buSzPct val="100000"/>
+              <a:buChar char="•"/>
+            </a:pPr>
+            <a:r>
+              <a:rPr lang="en-US" sz="1100" dirty="0">
+                <a:solidFill>
+                  <a:srgbClr val="24303C"/>
+                </a:solidFill>
+                <a:latin typeface="Calibri" pitchFamily="34" charset="0"/>
+                <a:ea typeface="Calibri" pitchFamily="34" charset="-122"/>
+                <a:cs typeface="Calibri" pitchFamily="34" charset="-120"/>
+              </a:rPr>
+              <a:t>The government-verified Round-2 gold (CN·IN·ID·LA·MN·RU·TH) is already ingested as the 8-economy eval baseline.</a:t>
+            </a:r>
+            <a:endParaRPr lang="en-US" sz="1100" dirty="0"/>
+          </a:p>
+        </p:txBody>
+      </p:sp>
+    </p:spTree>
+  </p:cSld>
+  <p:clrMapOvr>
+    <a:masterClrMapping/>
+  </p:clrMapOvr>
+</p:sld>
+</file>
+
+<file path=ppt/slides/slide15.xml><?xml version="1.0" encoding="utf-8"?>
+<p:sld xmlns:a="http://schemas.openxmlformats.org/drawingml/2006/main" xmlns:r="http://schemas.openxmlformats.org/officeDocument/2006/relationships" xmlns:p="http://schemas.openxmlformats.org/presentationml/2006/main">
+  <p:cSld name="Slide 15">
+    <p:bg>
+      <p:bgPr>
+        <a:solidFill>
+          <a:srgbClr val="FFFFFF"/>
+        </a:solidFill>
+      </p:bgPr>
+    </p:bg>
+    <p:spTree>
+      <p:nvGrpSpPr>
+        <p:cNvPr id="1" name=""/>
+        <p:cNvGrpSpPr/>
+        <p:nvPr/>
+      </p:nvGrpSpPr>
+      <p:grpSpPr>
+        <a:xfrm>
+          <a:off x="0" y="0"/>
+          <a:ext cx="0" cy="0"/>
+          <a:chOff x="0" y="0"/>
+          <a:chExt cx="0" cy="0"/>
+        </a:xfrm>
+      </p:grpSpPr>
+      <p:sp>
+        <p:nvSpPr>
+          <p:cNvPr id="2" name="Text 0"/>
+          <p:cNvSpPr/>
+          <p:nvPr/>
+        </p:nvSpPr>
+        <p:spPr>
+          <a:xfrm>
+            <a:off x="548640" y="292608"/>
+            <a:ext cx="11064240" cy="292608"/>
+          </a:xfrm>
+          <a:prstGeom prst="rect">
+            <a:avLst/>
+          </a:prstGeom>
+          <a:noFill/>
+          <a:ln/>
+        </p:spPr>
+        <p:txBody>
+          <a:bodyPr wrap="square" rtlCol="0" anchor="ctr"/>
+          <a:lstStyle/>
+          <a:p>
+            <a:pPr indent="0" marL="0">
+              <a:buNone/>
+            </a:pPr>
+            <a:r>
+              <a:rPr lang="en-US" sz="1200" b="1" spc="200" kern="0" dirty="0">
+                <a:solidFill>
+                  <a:srgbClr val="0E9E8E"/>
+                </a:solidFill>
+                <a:latin typeface="Calibri" pitchFamily="34" charset="0"/>
+                <a:ea typeface="Calibri" pitchFamily="34" charset="-122"/>
+                <a:cs typeface="Calibri" pitchFamily="34" charset="-120"/>
+              </a:rPr>
+              <a:t>FROM 3 ECONOMIES TO THE REGION</a:t>
+            </a:r>
+            <a:endParaRPr lang="en-US" sz="1200" dirty="0"/>
+          </a:p>
+        </p:txBody>
+      </p:sp>
+      <p:sp>
+        <p:nvSpPr>
+          <p:cNvPr id="3" name="Text 1"/>
+          <p:cNvSpPr/>
+          <p:nvPr/>
+        </p:nvSpPr>
+        <p:spPr>
+          <a:xfrm>
+            <a:off x="548640" y="530352"/>
+            <a:ext cx="11064240" cy="685800"/>
+          </a:xfrm>
+          <a:prstGeom prst="rect">
+            <a:avLst/>
+          </a:prstGeom>
+          <a:noFill/>
+          <a:ln/>
+        </p:spPr>
+        <p:txBody>
+          <a:bodyPr wrap="square" rtlCol="0" anchor="ctr"/>
+          <a:lstStyle/>
+          <a:p>
+            <a:pPr indent="0" marL="0">
+              <a:buNone/>
+            </a:pPr>
+            <a:r>
+              <a:rPr lang="en-US" sz="3400" b="1" dirty="0">
+                <a:solidFill>
+                  <a:srgbClr val="0F2A47"/>
+                </a:solidFill>
+                <a:latin typeface="Cambria" pitchFamily="34" charset="0"/>
+                <a:ea typeface="Cambria" pitchFamily="34" charset="-122"/>
+                <a:cs typeface="Cambria" pitchFamily="34" charset="-120"/>
+              </a:rPr>
+              <a:t>Scalability &amp; Future Development</a:t>
+            </a:r>
+            <a:endParaRPr lang="en-US" sz="3400" dirty="0"/>
+          </a:p>
+        </p:txBody>
+      </p:sp>
+      <p:sp>
+        <p:nvSpPr>
+          <p:cNvPr id="4" name="Shape 2"/>
+          <p:cNvSpPr/>
+          <p:nvPr/>
+        </p:nvSpPr>
+        <p:spPr>
+          <a:xfrm>
+            <a:off x="548640" y="1417320"/>
+            <a:ext cx="5486400" cy="4800600"/>
+          </a:xfrm>
+          <a:prstGeom prst="roundRect">
+            <a:avLst>
+              <a:gd name="adj" fmla="val 1524"/>
+            </a:avLst>
+          </a:prstGeom>
+          <a:solidFill>
+            <a:srgbClr val="EDF5FC"/>
+          </a:solidFill>
+          <a:ln/>
+        </p:spPr>
+      </p:sp>
+      <p:sp>
+        <p:nvSpPr>
+          <p:cNvPr id="5" name="Text 3"/>
+          <p:cNvSpPr/>
+          <p:nvPr/>
+        </p:nvSpPr>
+        <p:spPr>
+          <a:xfrm>
+            <a:off x="822960" y="1600200"/>
+            <a:ext cx="4937760" cy="320040"/>
+          </a:xfrm>
+          <a:prstGeom prst="rect">
+            <a:avLst/>
+          </a:prstGeom>
+          <a:noFill/>
+          <a:ln/>
+        </p:spPr>
+        <p:txBody>
+          <a:bodyPr wrap="square" rtlCol="0" anchor="ctr"/>
+          <a:lstStyle/>
+          <a:p>
+            <a:pPr indent="0" marL="0">
+              <a:buNone/>
+            </a:pPr>
+            <a:r>
+              <a:rPr lang="en-US" sz="1300" b="1" spc="100" kern="0" dirty="0">
+                <a:solidFill>
+                  <a:srgbClr val="0E9E8E"/>
+                </a:solidFill>
+                <a:latin typeface="Calibri" pitchFamily="34" charset="0"/>
+                <a:ea typeface="Calibri" pitchFamily="34" charset="-122"/>
+                <a:cs typeface="Calibri" pitchFamily="34" charset="-120"/>
+              </a:rPr>
+              <a:t>SCALE PATH</a:t>
+            </a:r>
+            <a:endParaRPr lang="en-US" sz="1300" dirty="0"/>
+          </a:p>
+        </p:txBody>
+      </p:sp>
+      <p:sp>
+        <p:nvSpPr>
+          <p:cNvPr id="6" name="Text 4"/>
+          <p:cNvSpPr/>
+          <p:nvPr/>
+        </p:nvSpPr>
+        <p:spPr>
+          <a:xfrm>
+            <a:off x="822960" y="1965960"/>
+            <a:ext cx="4937760" cy="4023360"/>
+          </a:xfrm>
+          <a:prstGeom prst="rect">
+            <a:avLst/>
+          </a:prstGeom>
+          <a:noFill/>
+          <a:ln/>
+        </p:spPr>
+        <p:txBody>
+          <a:bodyPr wrap="square" rtlCol="0" anchor="t"/>
+          <a:lstStyle/>
+          <a:p>
+            <a:pPr marL="342900" indent="-342900">
+              <a:spcAft>
+                <a:spcPts val="800"/>
+              </a:spcAft>
+              <a:buSzPct val="100000"/>
+              <a:buChar char="•"/>
+            </a:pPr>
+            <a:r>
+              <a:rPr lang="en-US" sz="1150" dirty="0">
+                <a:solidFill>
+                  <a:srgbClr val="24303C"/>
+                </a:solidFill>
+                <a:latin typeface="Calibri" pitchFamily="34" charset="0"/>
+                <a:ea typeface="Calibri" pitchFamily="34" charset="-122"/>
+                <a:cs typeface="Calibri" pitchFamily="34" charset="-120"/>
+              </a:rPr>
+              <a:t>New economy = data, not code: a jurisdiction YAML (portals, citation grammar, status assertions) + seed rows. Extractors are format-based; grammars are named profiles ("Pasal", "Статья", "มาตรา" next).</a:t>
+            </a:r>
+            <a:endParaRPr lang="en-US" sz="1150" dirty="0"/>
+          </a:p>
+          <a:p>
+            <a:pPr marL="342900" indent="-342900">
+              <a:spcAft>
+                <a:spcPts val="800"/>
+              </a:spcAft>
+              <a:buSzPct val="100000"/>
+              <a:buChar char="•"/>
+            </a:pPr>
+            <a:r>
+              <a:rPr lang="en-US" sz="1150" dirty="0">
+                <a:solidFill>
+                  <a:srgbClr val="24303C"/>
+                </a:solidFill>
+                <a:latin typeface="Calibri" pitchFamily="34" charset="0"/>
+                <a:ea typeface="Calibri" pitchFamily="34" charset="-122"/>
+                <a:cs typeface="Calibri" pitchFamily="34" charset="-120"/>
+              </a:rPr>
+              <a:t>Finals-ready gold: the government-verified Round-2 database (CN·IN·ID·LA·MN·RU·TH) is already ingested as the evaluation baseline for the 8-economy expansion.</a:t>
+            </a:r>
+            <a:endParaRPr lang="en-US" sz="1150" dirty="0"/>
+          </a:p>
+          <a:p>
+            <a:pPr marL="342900" indent="-342900">
+              <a:spcAft>
+                <a:spcPts val="800"/>
+              </a:spcAft>
+              <a:buSzPct val="100000"/>
+              <a:buChar char="•"/>
+            </a:pPr>
+            <a:r>
+              <a:rPr lang="en-US" sz="1150" dirty="0">
+                <a:solidFill>
+                  <a:srgbClr val="24303C"/>
+                </a:solidFill>
+                <a:latin typeface="Calibri" pitchFamily="34" charset="0"/>
+                <a:ea typeface="Calibri" pitchFamily="34" charset="-122"/>
+                <a:cs typeface="Calibri" pitchFamily="34" charset="-120"/>
+              </a:rPr>
+              <a:t>Multilingual by architecture: BGE-M3 cross-lingual retrieval, original-language verbatim + appended English column, per-language section grammars.</a:t>
+            </a:r>
+            <a:endParaRPr lang="en-US" sz="1150" dirty="0"/>
+          </a:p>
+          <a:p>
+            <a:pPr marL="342900" indent="-342900">
+              <a:buSzPct val="100000"/>
+              <a:buChar char="•"/>
+            </a:pPr>
+            <a:r>
+              <a:rPr lang="en-US" sz="1150" dirty="0">
+                <a:solidFill>
+                  <a:srgbClr val="24303C"/>
+                </a:solidFill>
+                <a:latin typeface="Calibri" pitchFamily="34" charset="0"/>
+                <a:ea typeface="Calibri" pitchFamily="34" charset="-122"/>
+                <a:cs typeface="Calibri" pitchFamily="34" charset="-120"/>
+              </a:rPr>
+              <a:t>Continuous monitoring: incremental fingerprints mean a nightly run re-extracts only changed documents — amendment tracking falls out of the cache design.</a:t>
+            </a:r>
+            <a:endParaRPr lang="en-US" sz="1150" dirty="0"/>
+          </a:p>
+        </p:txBody>
+      </p:sp>
+      <p:sp>
+        <p:nvSpPr>
+          <p:cNvPr id="7" name="Shape 5"/>
+          <p:cNvSpPr/>
+          <p:nvPr/>
+        </p:nvSpPr>
+        <p:spPr>
+          <a:xfrm>
+            <a:off x="6309360" y="1417320"/>
+            <a:ext cx="5303520" cy="4800600"/>
+          </a:xfrm>
+          <a:prstGeom prst="roundRect">
+            <a:avLst>
+              <a:gd name="adj" fmla="val 1524"/>
+            </a:avLst>
+          </a:prstGeom>
+          <a:solidFill>
+            <a:srgbClr val="F3FBF9"/>
+          </a:solidFill>
+          <a:ln/>
+        </p:spPr>
+      </p:sp>
+      <p:sp>
+        <p:nvSpPr>
+          <p:cNvPr id="8" name="Text 6"/>
+          <p:cNvSpPr/>
+          <p:nvPr/>
+        </p:nvSpPr>
+        <p:spPr>
+          <a:xfrm>
+            <a:off x="6583680" y="1600200"/>
+            <a:ext cx="4754880" cy="320040"/>
+          </a:xfrm>
+          <a:prstGeom prst="rect">
+            <a:avLst/>
+          </a:prstGeom>
+          <a:noFill/>
+          <a:ln/>
+        </p:spPr>
+        <p:txBody>
+          <a:bodyPr wrap="square" rtlCol="0" anchor="ctr"/>
+          <a:lstStyle/>
+          <a:p>
+            <a:pPr indent="0" marL="0">
+              <a:buNone/>
+            </a:pPr>
+            <a:r>
+              <a:rPr lang="en-US" sz="1300" b="1" spc="100" kern="0" dirty="0">
+                <a:solidFill>
+                  <a:srgbClr val="0E9E8E"/>
+                </a:solidFill>
+                <a:latin typeface="Calibri" pitchFamily="34" charset="0"/>
+                <a:ea typeface="Calibri" pitchFamily="34" charset="-122"/>
+                <a:cs typeface="Calibri" pitchFamily="34" charset="-120"/>
+              </a:rPr>
+              <a:t>VALUE FOR ESCAP &amp; STAKEHOLDERS</a:t>
+            </a:r>
+            <a:endParaRPr lang="en-US" sz="1300" dirty="0"/>
+          </a:p>
+        </p:txBody>
+      </p:sp>
+      <p:sp>
+        <p:nvSpPr>
+          <p:cNvPr id="9" name="Text 7"/>
+          <p:cNvSpPr/>
+          <p:nvPr/>
+        </p:nvSpPr>
+        <p:spPr>
+          <a:xfrm>
+            <a:off x="6583680" y="1965960"/>
+            <a:ext cx="4754880" cy="4023360"/>
+          </a:xfrm>
+          <a:prstGeom prst="rect">
+            <a:avLst/>
+          </a:prstGeom>
+          <a:noFill/>
+          <a:ln/>
+        </p:spPr>
+        <p:txBody>
+          <a:bodyPr wrap="square" rtlCol="0" anchor="t"/>
+          <a:lstStyle/>
+          <a:p>
+            <a:pPr marL="342900" indent="-342900">
+              <a:spcAft>
+                <a:spcPts val="800"/>
+              </a:spcAft>
+              <a:buSzPct val="100000"/>
+              <a:buChar char="•"/>
+            </a:pPr>
+            <a:r>
+              <a:rPr lang="en-US" sz="1150" dirty="0">
+                <a:solidFill>
+                  <a:srgbClr val="24303C"/>
+                </a:solidFill>
+                <a:latin typeface="Calibri" pitchFamily="34" charset="0"/>
+                <a:ea typeface="Calibri" pitchFamily="34" charset="-122"/>
+                <a:cs typeface="Calibri" pitchFamily="34" charset="-120"/>
+              </a:rPr>
+              <a:t>ESCAP researchers — RDTII updates in hours instead of months, with every cell traceable to an archived official source.</a:t>
+            </a:r>
+            <a:endParaRPr lang="en-US" sz="1150" dirty="0"/>
+          </a:p>
+          <a:p>
+            <a:pPr marL="342900" indent="-342900">
+              <a:spcAft>
+                <a:spcPts val="800"/>
+              </a:spcAft>
+              <a:buSzPct val="100000"/>
+              <a:buChar char="•"/>
+            </a:pPr>
+            <a:r>
+              <a:rPr lang="en-US" sz="1150" dirty="0">
+                <a:solidFill>
+                  <a:srgbClr val="24303C"/>
+                </a:solidFill>
+                <a:latin typeface="Calibri" pitchFamily="34" charset="0"/>
+                <a:ea typeface="Calibri" pitchFamily="34" charset="-122"/>
+                <a:cs typeface="Calibri" pitchFamily="34" charset="-120"/>
+              </a:rPr>
+              <a:t>Governments — see exactly which provision produced each score; corrections become data changes with receipts.</a:t>
+            </a:r>
+            <a:endParaRPr lang="en-US" sz="1150" dirty="0"/>
+          </a:p>
+          <a:p>
+            <a:pPr marL="342900" indent="-342900">
+              <a:spcAft>
+                <a:spcPts val="800"/>
+              </a:spcAft>
+              <a:buSzPct val="100000"/>
+              <a:buChar char="•"/>
+            </a:pPr>
+            <a:r>
+              <a:rPr lang="en-US" sz="1150" dirty="0">
+                <a:solidFill>
+                  <a:srgbClr val="24303C"/>
+                </a:solidFill>
+                <a:latin typeface="Calibri" pitchFamily="34" charset="0"/>
+                <a:ea typeface="Calibri" pitchFamily="34" charset="-122"/>
+                <a:cs typeface="Calibri" pitchFamily="34" charset="-120"/>
+              </a:rPr>
+              <a:t>Businesses &amp; trade lawyers — pinpoint, current, verifiable answers on cross-border data rules across jurisdictions.</a:t>
+            </a:r>
+            <a:endParaRPr lang="en-US" sz="1150" dirty="0"/>
+          </a:p>
+          <a:p>
+            <a:pPr marL="342900" indent="-342900">
+              <a:buSzPct val="100000"/>
+              <a:buChar char="•"/>
+            </a:pPr>
+            <a:r>
+              <a:rPr lang="en-US" sz="1150" dirty="0">
+                <a:solidFill>
+                  <a:srgbClr val="24303C"/>
+                </a:solidFill>
+                <a:latin typeface="Calibri" pitchFamily="34" charset="0"/>
+                <a:ea typeface="Calibri" pitchFamily="34" charset="-122"/>
+                <a:cs typeface="Calibri" pitchFamily="34" charset="-120"/>
+              </a:rPr>
+              <a:t>Expected outcomes — faster policy insight, fewer stale citations, lower compliance-research burden, and a reusable evidence commons for digital-trade regulation.</a:t>
+            </a:r>
+            <a:endParaRPr lang="en-US" sz="1150" dirty="0"/>
+          </a:p>
+        </p:txBody>
+      </p:sp>
+    </p:spTree>
+  </p:cSld>
+  <p:clrMapOvr>
+    <a:masterClrMapping/>
+  </p:clrMapOvr>
+</p:sld>
+</file>
+
+<file path=ppt/slides/slide16.xml><?xml version="1.0" encoding="utf-8"?>
+<p:sld xmlns:a="http://schemas.openxmlformats.org/drawingml/2006/main" xmlns:r="http://schemas.openxmlformats.org/officeDocument/2006/relationships" xmlns:p="http://schemas.openxmlformats.org/presentationml/2006/main">
+  <p:cSld name="Slide 16">
+    <p:bg>
+      <p:bgPr>
+        <a:solidFill>
+          <a:srgbClr val="0F2A47"/>
+        </a:solidFill>
+      </p:bgPr>
+    </p:bg>
+    <p:spTree>
+      <p:nvGrpSpPr>
+        <p:cNvPr id="1" name=""/>
+        <p:cNvGrpSpPr/>
+        <p:nvPr/>
+      </p:nvGrpSpPr>
+      <p:grpSpPr>
+        <a:xfrm>
+          <a:off x="0" y="0"/>
+          <a:ext cx="0" cy="0"/>
+          <a:chOff x="0" y="0"/>
+          <a:chExt cx="0" cy="0"/>
+        </a:xfrm>
+      </p:grpSpPr>
+      <p:sp>
+        <p:nvSpPr>
+          <p:cNvPr id="2" name="Text 0"/>
+          <p:cNvSpPr/>
+          <p:nvPr/>
+        </p:nvSpPr>
+        <p:spPr>
+          <a:xfrm>
+            <a:off x="640080" y="457200"/>
+            <a:ext cx="10972800" cy="365760"/>
+          </a:xfrm>
+          <a:prstGeom prst="rect">
+            <a:avLst/>
+          </a:prstGeom>
+          <a:noFill/>
+          <a:ln/>
+        </p:spPr>
+        <p:txBody>
+          <a:bodyPr wrap="square" rtlCol="0" anchor="ctr"/>
+          <a:lstStyle/>
+          <a:p>
+            <a:pPr indent="0" marL="0">
+              <a:buNone/>
+            </a:pPr>
+            <a:r>
+              <a:rPr lang="en-US" sz="1300" b="1" spc="200" kern="0" dirty="0">
+                <a:solidFill>
+                  <a:srgbClr val="0E9E8E"/>
+                </a:solidFill>
+                <a:latin typeface="Calibri" pitchFamily="34" charset="0"/>
+                <a:ea typeface="Calibri" pitchFamily="34" charset="-122"/>
+                <a:cs typeface="Calibri" pitchFamily="34" charset="-120"/>
+              </a:rPr>
+              <a:t>THE CHAMPIONSHIP CASE</a:t>
+            </a:r>
+            <a:endParaRPr lang="en-US" sz="1300" dirty="0"/>
+          </a:p>
+        </p:txBody>
+      </p:sp>
+      <p:sp>
+        <p:nvSpPr>
+          <p:cNvPr id="3" name="Text 1"/>
+          <p:cNvSpPr/>
+          <p:nvPr/>
+        </p:nvSpPr>
+        <p:spPr>
+          <a:xfrm>
+            <a:off x="640080" y="822960"/>
+            <a:ext cx="10972800" cy="685800"/>
+          </a:xfrm>
+          <a:prstGeom prst="rect">
+            <a:avLst/>
+          </a:prstGeom>
+          <a:noFill/>
+          <a:ln/>
+        </p:spPr>
+        <p:txBody>
+          <a:bodyPr wrap="square" rtlCol="0" anchor="ctr"/>
+          <a:lstStyle/>
+          <a:p>
+            <a:pPr indent="0" marL="0">
+              <a:buNone/>
+            </a:pPr>
+            <a:r>
+              <a:rPr lang="en-US" sz="3400" b="1" dirty="0">
+                <a:solidFill>
+                  <a:srgbClr val="FFFFFF"/>
+                </a:solidFill>
+                <a:latin typeface="Cambria" pitchFamily="34" charset="0"/>
+                <a:ea typeface="Cambria" pitchFamily="34" charset="-122"/>
+                <a:cs typeface="Cambria" pitchFamily="34" charset="-120"/>
+              </a:rPr>
+              <a:t>Why ClauseChain should win</a:t>
+            </a:r>
+            <a:endParaRPr lang="en-US" sz="3400" dirty="0"/>
+          </a:p>
+        </p:txBody>
+      </p:sp>
+      <p:sp>
+        <p:nvSpPr>
+          <p:cNvPr id="4" name="Shape 2"/>
+          <p:cNvSpPr/>
+          <p:nvPr/>
+        </p:nvSpPr>
+        <p:spPr>
+          <a:xfrm>
+            <a:off x="640080" y="1737360"/>
+            <a:ext cx="3593592" cy="4251960"/>
+          </a:xfrm>
+          <a:prstGeom prst="roundRect">
+            <a:avLst>
+              <a:gd name="adj" fmla="val 2036"/>
+            </a:avLst>
+          </a:prstGeom>
+          <a:solidFill>
+            <a:srgbClr val="16395C"/>
+          </a:solidFill>
+          <a:ln/>
+        </p:spPr>
+      </p:sp>
+      <p:sp>
+        <p:nvSpPr>
+          <p:cNvPr id="5" name="Text 3"/>
+          <p:cNvSpPr/>
+          <p:nvPr/>
+        </p:nvSpPr>
+        <p:spPr>
+          <a:xfrm>
+            <a:off x="868680" y="1920240"/>
+            <a:ext cx="3154680" cy="320040"/>
+          </a:xfrm>
+          <a:prstGeom prst="rect">
+            <a:avLst/>
+          </a:prstGeom>
+          <a:noFill/>
+          <a:ln/>
+        </p:spPr>
+        <p:txBody>
+          <a:bodyPr wrap="square" rtlCol="0" anchor="ctr"/>
+          <a:lstStyle/>
+          <a:p>
+            <a:pPr indent="0" marL="0">
+              <a:buNone/>
+            </a:pPr>
+            <a:r>
+              <a:rPr lang="en-US" sz="1150" b="1" spc="100" kern="0" dirty="0">
+                <a:solidFill>
+                  <a:srgbClr val="D9A441"/>
+                </a:solidFill>
+                <a:latin typeface="Calibri" pitchFamily="34" charset="0"/>
+                <a:ea typeface="Calibri" pitchFamily="34" charset="-122"/>
+                <a:cs typeface="Calibri" pitchFamily="34" charset="-120"/>
+              </a:rPr>
+              <a:t>SUBSTANTIVE ACCURACY · 40%</a:t>
+            </a:r>
+            <a:endParaRPr lang="en-US" sz="1150" dirty="0"/>
+          </a:p>
+        </p:txBody>
+      </p:sp>
+      <p:sp>
+        <p:nvSpPr>
+          <p:cNvPr id="6" name="Text 4"/>
+          <p:cNvSpPr/>
+          <p:nvPr/>
+        </p:nvSpPr>
+        <p:spPr>
+          <a:xfrm>
+            <a:off x="868680" y="2286000"/>
+            <a:ext cx="3154680" cy="3566160"/>
+          </a:xfrm>
+          <a:prstGeom prst="rect">
+            <a:avLst/>
+          </a:prstGeom>
+          <a:noFill/>
+          <a:ln/>
+        </p:spPr>
+        <p:txBody>
+          <a:bodyPr wrap="square" rtlCol="0" anchor="t"/>
+          <a:lstStyle/>
+          <a:p>
+            <a:pPr marL="342900" indent="-342900">
+              <a:spcAft>
+                <a:spcPts val="900"/>
+              </a:spcAft>
+              <a:buSzPct val="100000"/>
+              <a:buChar char="•"/>
+            </a:pPr>
+            <a:r>
+              <a:rPr lang="en-US" sz="1030" dirty="0">
+                <a:solidFill>
+                  <a:srgbClr val="DCE8F5"/>
+                </a:solidFill>
+                <a:latin typeface="Calibri" pitchFamily="34" charset="0"/>
+                <a:ea typeface="Calibri" pitchFamily="34" charset="-122"/>
+                <a:cs typeface="Calibri" pitchFamily="34" charset="-120"/>
+              </a:rPr>
+              <a:t>74 provision-level NEW findings beyond the sample kit — the 20-point lever, systematically harvested</a:t>
+            </a:r>
+            <a:endParaRPr lang="en-US" sz="1030" dirty="0"/>
+          </a:p>
+          <a:p>
+            <a:pPr marL="342900" indent="-342900">
+              <a:spcAft>
+                <a:spcPts val="900"/>
+              </a:spcAft>
+              <a:buSzPct val="100000"/>
+              <a:buChar char="•"/>
+            </a:pPr>
+            <a:r>
+              <a:rPr lang="en-US" sz="1030" dirty="0">
+                <a:solidFill>
+                  <a:srgbClr val="DCE8F5"/>
+                </a:solidFill>
+                <a:latin typeface="Calibri" pitchFamily="34" charset="0"/>
+                <a:ea typeface="Calibri" pitchFamily="34" charset="-122"/>
+                <a:cs typeface="Calibri" pitchFamily="34" charset="-120"/>
+              </a:rPr>
+              <a:t>First treaty-evidenced P6-I5 rows (CPTPP 14.11, DEPA 4.3, RCEP 12.15) from official registers</a:t>
+            </a:r>
+            <a:endParaRPr lang="en-US" sz="1030" dirty="0"/>
+          </a:p>
+          <a:p>
+            <a:pPr marL="342900" indent="-342900">
+              <a:spcAft>
+                <a:spcPts val="900"/>
+              </a:spcAft>
+              <a:buSzPct val="100000"/>
+              <a:buChar char="•"/>
+            </a:pPr>
+            <a:r>
+              <a:rPr lang="en-US" sz="1030" dirty="0">
+                <a:solidFill>
+                  <a:srgbClr val="DCE8F5"/>
+                </a:solidFill>
+                <a:latin typeface="Calibri" pitchFamily="34" charset="0"/>
+                <a:ea typeface="Calibri" pitchFamily="34" charset="-122"/>
+                <a:cs typeface="Calibri" pitchFamily="34" charset="-120"/>
+              </a:rPr>
+              <a:t>Byte-exact citations a lawyer verifies in seconds; polarity traps encoded as rubric data</a:t>
+            </a:r>
+            <a:endParaRPr lang="en-US" sz="1030" dirty="0"/>
+          </a:p>
+          <a:p>
+            <a:pPr marL="342900" indent="-342900">
+              <a:spcAft>
+                <a:spcPts val="900"/>
+              </a:spcAft>
+              <a:buSzPct val="100000"/>
+              <a:buChar char="•"/>
+            </a:pPr>
+            <a:r>
+              <a:rPr lang="en-US" sz="1030" dirty="0">
+                <a:solidFill>
+                  <a:srgbClr val="DCE8F5"/>
+                </a:solidFill>
+                <a:latin typeface="Calibri" pitchFamily="34" charset="0"/>
+                <a:ea typeface="Calibri" pitchFamily="34" charset="-122"/>
+                <a:cs typeface="Calibri" pitchFamily="34" charset="-120"/>
+              </a:rPr>
+              <a:t>We audited the gold itself and caught the planted Malaysia errors — with receipts</a:t>
+            </a:r>
+            <a:endParaRPr lang="en-US" sz="1030" dirty="0"/>
+          </a:p>
+        </p:txBody>
+      </p:sp>
+      <p:sp>
+        <p:nvSpPr>
+          <p:cNvPr id="7" name="Shape 5"/>
+          <p:cNvSpPr/>
+          <p:nvPr/>
+        </p:nvSpPr>
+        <p:spPr>
+          <a:xfrm>
+            <a:off x="4416552" y="1737360"/>
+            <a:ext cx="3593592" cy="4251960"/>
+          </a:xfrm>
+          <a:prstGeom prst="roundRect">
+            <a:avLst>
+              <a:gd name="adj" fmla="val 2036"/>
+            </a:avLst>
+          </a:prstGeom>
+          <a:solidFill>
+            <a:srgbClr val="16395C"/>
+          </a:solidFill>
+          <a:ln/>
+        </p:spPr>
+      </p:sp>
+      <p:sp>
+        <p:nvSpPr>
+          <p:cNvPr id="8" name="Text 6"/>
+          <p:cNvSpPr/>
+          <p:nvPr/>
+        </p:nvSpPr>
+        <p:spPr>
+          <a:xfrm>
+            <a:off x="4645152" y="1920240"/>
+            <a:ext cx="3154680" cy="320040"/>
+          </a:xfrm>
+          <a:prstGeom prst="rect">
+            <a:avLst/>
+          </a:prstGeom>
+          <a:noFill/>
+          <a:ln/>
+        </p:spPr>
+        <p:txBody>
+          <a:bodyPr wrap="square" rtlCol="0" anchor="ctr"/>
+          <a:lstStyle/>
+          <a:p>
+            <a:pPr indent="0" marL="0">
+              <a:buNone/>
+            </a:pPr>
+            <a:r>
+              <a:rPr lang="en-US" sz="1150" b="1" spc="100" kern="0" dirty="0">
+                <a:solidFill>
+                  <a:srgbClr val="D9A441"/>
+                </a:solidFill>
+                <a:latin typeface="Calibri" pitchFamily="34" charset="0"/>
+                <a:ea typeface="Calibri" pitchFamily="34" charset="-122"/>
+                <a:cs typeface="Calibri" pitchFamily="34" charset="-120"/>
+              </a:rPr>
+              <a:t>TECHNICAL RESILIENCE · 30%</a:t>
+            </a:r>
+            <a:endParaRPr lang="en-US" sz="1150" dirty="0"/>
+          </a:p>
+        </p:txBody>
+      </p:sp>
+      <p:sp>
+        <p:nvSpPr>
+          <p:cNvPr id="9" name="Text 7"/>
+          <p:cNvSpPr/>
+          <p:nvPr/>
+        </p:nvSpPr>
+        <p:spPr>
+          <a:xfrm>
+            <a:off x="4645152" y="2286000"/>
+            <a:ext cx="3154680" cy="3566160"/>
+          </a:xfrm>
+          <a:prstGeom prst="rect">
+            <a:avLst/>
+          </a:prstGeom>
+          <a:noFill/>
+          <a:ln/>
+        </p:spPr>
+        <p:txBody>
+          <a:bodyPr wrap="square" rtlCol="0" anchor="t"/>
+          <a:lstStyle/>
+          <a:p>
+            <a:pPr marL="342900" indent="-342900">
+              <a:spcAft>
+                <a:spcPts val="900"/>
+              </a:spcAft>
+              <a:buSzPct val="100000"/>
+              <a:buChar char="•"/>
+            </a:pPr>
+            <a:r>
+              <a:rPr lang="en-US" sz="1030" dirty="0">
+                <a:solidFill>
+                  <a:srgbClr val="DCE8F5"/>
+                </a:solidFill>
+                <a:latin typeface="Calibri" pitchFamily="34" charset="0"/>
+                <a:ea typeface="Calibri" pitchFamily="34" charset="-122"/>
+                <a:cs typeface="Calibri" pitchFamily="34" charset="-120"/>
+              </a:rPr>
+              <a:t>Live portals with anti-bot walls beaten (backoff + real-browser fallback); failures recorded, never faked</a:t>
+            </a:r>
+            <a:endParaRPr lang="en-US" sz="1030" dirty="0"/>
+          </a:p>
+          <a:p>
+            <a:pPr marL="342900" indent="-342900">
+              <a:spcAft>
+                <a:spcPts val="900"/>
+              </a:spcAft>
+              <a:buSzPct val="100000"/>
+              <a:buChar char="•"/>
+            </a:pPr>
+            <a:r>
+              <a:rPr lang="en-US" sz="1030" dirty="0">
+                <a:solidFill>
+                  <a:srgbClr val="DCE8F5"/>
+                </a:solidFill>
+                <a:latin typeface="Calibri" pitchFamily="34" charset="0"/>
+                <a:ea typeface="Calibri" pitchFamily="34" charset="-122"/>
+                <a:cs typeface="Calibri" pitchFamily="34" charset="-120"/>
+              </a:rPr>
+              <a:t>Scanned gazettes: OCR with per-page confidence + statutory glyph repair; bilingual Malay grammar</a:t>
+            </a:r>
+            <a:endParaRPr lang="en-US" sz="1030" dirty="0"/>
+          </a:p>
+          <a:p>
+            <a:pPr marL="342900" indent="-342900">
+              <a:spcAft>
+                <a:spcPts val="900"/>
+              </a:spcAft>
+              <a:buSzPct val="100000"/>
+              <a:buChar char="•"/>
+            </a:pPr>
+            <a:r>
+              <a:rPr lang="en-US" sz="1030" dirty="0">
+                <a:solidFill>
+                  <a:srgbClr val="DCE8F5"/>
+                </a:solidFill>
+                <a:latin typeface="Calibri" pitchFamily="34" charset="0"/>
+                <a:ea typeface="Calibri" pitchFamily="34" charset="-122"/>
+                <a:cs typeface="Calibri" pitchFamily="34" charset="-120"/>
+              </a:rPr>
+              <a:t>End-to-end with zero manual steps — and a web console that triggers the same engine</a:t>
+            </a:r>
+            <a:endParaRPr lang="en-US" sz="1030" dirty="0"/>
+          </a:p>
+          <a:p>
+            <a:pPr marL="342900" indent="-342900">
+              <a:spcAft>
+                <a:spcPts val="900"/>
+              </a:spcAft>
+              <a:buSzPct val="100000"/>
+              <a:buChar char="•"/>
+            </a:pPr>
+            <a:r>
+              <a:rPr lang="en-US" sz="1030" dirty="0">
+                <a:solidFill>
+                  <a:srgbClr val="DCE8F5"/>
+                </a:solidFill>
+                <a:latin typeface="Calibri" pitchFamily="34" charset="0"/>
+                <a:ea typeface="Calibri" pitchFamily="34" charset="-122"/>
+                <a:cs typeface="Calibri" pitchFamily="34" charset="-120"/>
+              </a:rPr>
+              <a:t>Incremental fingerprints: nightly re-runs re-extract only changed law</a:t>
+            </a:r>
+            <a:endParaRPr lang="en-US" sz="1030" dirty="0"/>
+          </a:p>
+        </p:txBody>
+      </p:sp>
+      <p:sp>
+        <p:nvSpPr>
+          <p:cNvPr id="10" name="Shape 8"/>
+          <p:cNvSpPr/>
+          <p:nvPr/>
+        </p:nvSpPr>
+        <p:spPr>
+          <a:xfrm>
+            <a:off x="8193024" y="1737360"/>
+            <a:ext cx="3593592" cy="4251960"/>
+          </a:xfrm>
+          <a:prstGeom prst="roundRect">
+            <a:avLst>
+              <a:gd name="adj" fmla="val 2036"/>
+            </a:avLst>
+          </a:prstGeom>
+          <a:solidFill>
+            <a:srgbClr val="16395C"/>
+          </a:solidFill>
+          <a:ln/>
+        </p:spPr>
+      </p:sp>
+      <p:sp>
+        <p:nvSpPr>
+          <p:cNvPr id="11" name="Text 9"/>
+          <p:cNvSpPr/>
+          <p:nvPr/>
+        </p:nvSpPr>
+        <p:spPr>
+          <a:xfrm>
+            <a:off x="8421624" y="1920240"/>
+            <a:ext cx="3154680" cy="320040"/>
+          </a:xfrm>
+          <a:prstGeom prst="rect">
+            <a:avLst/>
+          </a:prstGeom>
+          <a:noFill/>
+          <a:ln/>
+        </p:spPr>
+        <p:txBody>
+          <a:bodyPr wrap="square" rtlCol="0" anchor="ctr"/>
+          <a:lstStyle/>
+          <a:p>
+            <a:pPr indent="0" marL="0">
+              <a:buNone/>
+            </a:pPr>
+            <a:r>
+              <a:rPr lang="en-US" sz="1150" b="1" spc="100" kern="0" dirty="0">
+                <a:solidFill>
+                  <a:srgbClr val="D9A441"/>
+                </a:solidFill>
+                <a:latin typeface="Calibri" pitchFamily="34" charset="0"/>
+                <a:ea typeface="Calibri" pitchFamily="34" charset="-122"/>
+                <a:cs typeface="Calibri" pitchFamily="34" charset="-120"/>
+              </a:rPr>
+              <a:t>ARCHITECTURE · 30%</a:t>
+            </a:r>
+            <a:endParaRPr lang="en-US" sz="1150" dirty="0"/>
+          </a:p>
+        </p:txBody>
+      </p:sp>
+      <p:sp>
+        <p:nvSpPr>
+          <p:cNvPr id="12" name="Text 10"/>
+          <p:cNvSpPr/>
+          <p:nvPr/>
+        </p:nvSpPr>
+        <p:spPr>
+          <a:xfrm>
+            <a:off x="8421624" y="2286000"/>
+            <a:ext cx="3154680" cy="3566160"/>
+          </a:xfrm>
+          <a:prstGeom prst="rect">
+            <a:avLst/>
+          </a:prstGeom>
+          <a:noFill/>
+          <a:ln/>
+        </p:spPr>
+        <p:txBody>
+          <a:bodyPr wrap="square" rtlCol="0" anchor="t"/>
+          <a:lstStyle/>
+          <a:p>
+            <a:pPr marL="342900" indent="-342900">
+              <a:spcAft>
+                <a:spcPts val="900"/>
+              </a:spcAft>
+              <a:buSzPct val="100000"/>
+              <a:buChar char="•"/>
+            </a:pPr>
+            <a:r>
+              <a:rPr lang="en-US" sz="1030" dirty="0">
+                <a:solidFill>
+                  <a:srgbClr val="DCE8F5"/>
+                </a:solidFill>
+                <a:latin typeface="Calibri" pitchFamily="34" charset="0"/>
+                <a:ea typeface="Calibri" pitchFamily="34" charset="-122"/>
+                <a:cs typeface="Calibri" pitchFamily="34" charset="-120"/>
+              </a:rPr>
+              <a:t>Swap LLM / OCR / graph by config — two shipped profiles, incl. a fully key-free local path</a:t>
+            </a:r>
+            <a:endParaRPr lang="en-US" sz="1030" dirty="0"/>
+          </a:p>
+          <a:p>
+            <a:pPr marL="342900" indent="-342900">
+              <a:spcAft>
+                <a:spcPts val="900"/>
+              </a:spcAft>
+              <a:buSzPct val="100000"/>
+              <a:buChar char="•"/>
+            </a:pPr>
+            <a:r>
+              <a:rPr lang="en-US" sz="1030" dirty="0">
+                <a:solidFill>
+                  <a:srgbClr val="DCE8F5"/>
+                </a:solidFill>
+                <a:latin typeface="Calibri" pitchFamily="34" charset="0"/>
+                <a:ea typeface="Calibri" pitchFamily="34" charset="-122"/>
+                <a:cs typeface="Calibri" pitchFamily="34" charset="-120"/>
+              </a:rPr>
+              <a:t>Audit trail beyond the ask: verbatim snippet + archived source + SHA-256 + gate results + named review + replay</a:t>
+            </a:r>
+            <a:endParaRPr lang="en-US" sz="1030" dirty="0"/>
+          </a:p>
+          <a:p>
+            <a:pPr marL="342900" indent="-342900">
+              <a:spcAft>
+                <a:spcPts val="900"/>
+              </a:spcAft>
+              <a:buSzPct val="100000"/>
+              <a:buChar char="•"/>
+            </a:pPr>
+            <a:r>
+              <a:rPr lang="en-US" sz="1030" dirty="0">
+                <a:solidFill>
+                  <a:srgbClr val="DCE8F5"/>
+                </a:solidFill>
+                <a:latin typeface="Calibri" pitchFamily="34" charset="0"/>
+                <a:ea typeface="Calibri" pitchFamily="34" charset="-122"/>
+                <a:cs typeface="Calibri" pitchFamily="34" charset="-120"/>
+              </a:rPr>
+              <a:t>Measured cost: US$1.16 for the entire 3-economy sweep (≈ $0.01 per document)</a:t>
+            </a:r>
+            <a:endParaRPr lang="en-US" sz="1030" dirty="0"/>
+          </a:p>
+          <a:p>
+            <a:pPr marL="342900" indent="-342900">
+              <a:spcAft>
+                <a:spcPts val="900"/>
+              </a:spcAft>
+              <a:buSzPct val="100000"/>
+              <a:buChar char="•"/>
+            </a:pPr>
+            <a:r>
+              <a:rPr lang="en-US" sz="1030" dirty="0">
+                <a:solidFill>
+                  <a:srgbClr val="DCE8F5"/>
+                </a:solidFill>
+                <a:latin typeface="Calibri" pitchFamily="34" charset="0"/>
+                <a:ea typeface="Calibri" pitchFamily="34" charset="-122"/>
+                <a:cs typeface="Calibri" pitchFamily="34" charset="-120"/>
+              </a:rPr>
+              <a:t>Adding an economy or pillar = one YAML + seed rows; finals gold already ingested</a:t>
+            </a:r>
+            <a:endParaRPr lang="en-US" sz="1030" dirty="0"/>
+          </a:p>
+        </p:txBody>
+      </p:sp>
+      <p:sp>
+        <p:nvSpPr>
+          <p:cNvPr id="13" name="Text 11"/>
+          <p:cNvSpPr/>
+          <p:nvPr/>
+        </p:nvSpPr>
+        <p:spPr>
+          <a:xfrm>
+            <a:off x="640080" y="6172200"/>
+            <a:ext cx="10972800" cy="411480"/>
+          </a:xfrm>
+          <a:prstGeom prst="rect">
+            <a:avLst/>
+          </a:prstGeom>
+          <a:noFill/>
+          <a:ln/>
+        </p:spPr>
+        <p:txBody>
+          <a:bodyPr wrap="square" rtlCol="0" anchor="ctr"/>
+          <a:lstStyle/>
+          <a:p>
+            <a:pPr algn="ctr" indent="0" marL="0">
+              <a:buNone/>
+            </a:pPr>
+            <a:r>
+              <a:rPr lang="en-US" sz="1600" i="1" dirty="0">
+                <a:solidFill>
+                  <a:srgbClr val="CADCFC"/>
+                </a:solidFill>
+                <a:latin typeface="Calibri" pitchFamily="34" charset="0"/>
+                <a:ea typeface="Calibri" pitchFamily="34" charset="-122"/>
+                <a:cs typeface="Calibri" pitchFamily="34" charset="-120"/>
+              </a:rPr>
+              <a:t>Trust is the product: every row the judges check will check out.</a:t>
+            </a:r>
+            <a:endParaRPr lang="en-US" sz="1600" dirty="0"/>
+          </a:p>
+        </p:txBody>
+      </p:sp>
+    </p:spTree>
+  </p:cSld>
+  <p:clrMapOvr>
+    <a:masterClrMapping/>
+  </p:clrMapOvr>
+</p:sld>
+</file>
+
+<file path=ppt/slides/slide17.xml><?xml version="1.0" encoding="utf-8"?>
+<p:sld xmlns:a="http://schemas.openxmlformats.org/drawingml/2006/main" xmlns:r="http://schemas.openxmlformats.org/officeDocument/2006/relationships" xmlns:p="http://schemas.openxmlformats.org/presentationml/2006/main">
+  <p:cSld name="Slide 17">
     <p:bg>
       <p:bgPr>
         <a:solidFill>

</xml_diff>